<commit_message>
Raise Unit 1 lesson standard: diagrams, mark schemes and slide variety.
Rebuild section slides with topic-specific teaching cards, add writing
space on question slides, upgrade labelled diagrams, and replace packed
one-page answers with worked multi-page mark schemes. Shop is unchanged.

Co-authored-by: moky107 <moky107@users.noreply.github.com>
</commit_message>
<xml_diff>
--- a/content/lessons/cell-structure/btec-unit-1-biology-cell-structure.pptx
+++ b/content/lessons/cell-structure/btec-unit-1-biology-cell-structure.pptx
@@ -3731,8 +3731,8 @@
         </p:nvSpPr>
         <p:spPr>
           <a:xfrm>
-            <a:off x="6931152" y="1069848"/>
-            <a:ext cx="4617720" cy="685800"/>
+            <a:off x="6931152" y="1051560"/>
+            <a:ext cx="4617720" cy="722376"/>
           </a:xfrm>
           <a:prstGeom prst="rect">
             <a:avLst/>
@@ -3850,8 +3850,8 @@
         </p:nvSpPr>
         <p:spPr>
           <a:xfrm>
-            <a:off x="6931152" y="2029968"/>
-            <a:ext cx="4617720" cy="685800"/>
+            <a:off x="6931152" y="2011680"/>
+            <a:ext cx="4617720" cy="722376"/>
           </a:xfrm>
           <a:prstGeom prst="rect">
             <a:avLst/>
@@ -3969,8 +3969,8 @@
         </p:nvSpPr>
         <p:spPr>
           <a:xfrm>
-            <a:off x="6931152" y="2990088"/>
-            <a:ext cx="4617720" cy="685800"/>
+            <a:off x="6931152" y="2971800"/>
+            <a:ext cx="4617720" cy="722376"/>
           </a:xfrm>
           <a:prstGeom prst="rect">
             <a:avLst/>
@@ -4088,8 +4088,8 @@
         </p:nvSpPr>
         <p:spPr>
           <a:xfrm>
-            <a:off x="6931152" y="3950208"/>
-            <a:ext cx="4617720" cy="685800"/>
+            <a:off x="6931152" y="3931920"/>
+            <a:ext cx="4617720" cy="722376"/>
           </a:xfrm>
           <a:prstGeom prst="rect">
             <a:avLst/>
@@ -4207,8 +4207,8 @@
         </p:nvSpPr>
         <p:spPr>
           <a:xfrm>
-            <a:off x="6931152" y="4910328"/>
-            <a:ext cx="4617720" cy="685800"/>
+            <a:off x="6931152" y="4892040"/>
+            <a:ext cx="4617720" cy="722376"/>
           </a:xfrm>
           <a:prstGeom prst="rect">
             <a:avLst/>
@@ -4610,8 +4610,8 @@
         </p:nvSpPr>
         <p:spPr>
           <a:xfrm>
-            <a:off x="6931152" y="1069848"/>
-            <a:ext cx="4617720" cy="685800"/>
+            <a:off x="6931152" y="1051560"/>
+            <a:ext cx="4617720" cy="722376"/>
           </a:xfrm>
           <a:prstGeom prst="rect">
             <a:avLst/>
@@ -4729,8 +4729,8 @@
         </p:nvSpPr>
         <p:spPr>
           <a:xfrm>
-            <a:off x="6931152" y="2029968"/>
-            <a:ext cx="4617720" cy="685800"/>
+            <a:off x="6931152" y="2011680"/>
+            <a:ext cx="4617720" cy="722376"/>
           </a:xfrm>
           <a:prstGeom prst="rect">
             <a:avLst/>
@@ -4848,8 +4848,8 @@
         </p:nvSpPr>
         <p:spPr>
           <a:xfrm>
-            <a:off x="6931152" y="2990088"/>
-            <a:ext cx="4617720" cy="685800"/>
+            <a:off x="6931152" y="2971800"/>
+            <a:ext cx="4617720" cy="722376"/>
           </a:xfrm>
           <a:prstGeom prst="rect">
             <a:avLst/>
@@ -4967,8 +4967,8 @@
         </p:nvSpPr>
         <p:spPr>
           <a:xfrm>
-            <a:off x="6931152" y="3950208"/>
-            <a:ext cx="4617720" cy="685800"/>
+            <a:off x="6931152" y="3931920"/>
+            <a:ext cx="4617720" cy="722376"/>
           </a:xfrm>
           <a:prstGeom prst="rect">
             <a:avLst/>
@@ -5086,8 +5086,8 @@
         </p:nvSpPr>
         <p:spPr>
           <a:xfrm>
-            <a:off x="6931152" y="4910328"/>
-            <a:ext cx="4617720" cy="685800"/>
+            <a:off x="6931152" y="4892040"/>
+            <a:ext cx="4617720" cy="722376"/>
           </a:xfrm>
           <a:prstGeom prst="rect">
             <a:avLst/>
@@ -5346,8 +5346,8 @@
         </p:nvSpPr>
         <p:spPr>
           <a:xfrm>
-            <a:off x="0" y="2880360"/>
-            <a:ext cx="12191695" cy="73152"/>
+            <a:off x="0" y="0"/>
+            <a:ext cx="146304" cy="6858000"/>
           </a:xfrm>
           <a:prstGeom prst="rect">
             <a:avLst/>
@@ -5389,80 +5389,80 @@
         </p:nvSpPr>
         <p:spPr>
           <a:xfrm>
+            <a:off x="640080" y="384048"/>
+            <a:ext cx="10972800" cy="868680"/>
+          </a:xfrm>
+          <a:prstGeom prst="rect">
+            <a:avLst/>
+          </a:prstGeom>
+          <a:noFill/>
+        </p:spPr>
+        <p:txBody>
+          <a:bodyPr wrap="square" anchor="t"/>
+          <a:lstStyle/>
+          <a:p>
+            <a:pPr algn="l"/>
+            <a:r>
+              <a:rPr sz="3000" b="1" i="0" a:ea="Calibri">
+                <a:solidFill>
+                  <a:srgbClr val="FFFFFF"/>
+                </a:solidFill>
+                <a:latin typeface="Calibri"/>
+              </a:rPr>
+              <a:t>Plant cell extras</a:t>
+            </a:r>
+          </a:p>
+        </p:txBody>
+      </p:sp>
+      <p:sp>
+        <p:nvSpPr>
+          <p:cNvPr id="5" name="TextBox 4"/>
+          <p:cNvSpPr txBox="1"/>
+          <p:nvPr/>
+        </p:nvSpPr>
+        <p:spPr>
+          <a:xfrm>
+            <a:off x="640080" y="1261872"/>
+            <a:ext cx="10972800" cy="502920"/>
+          </a:xfrm>
+          <a:prstGeom prst="rect">
+            <a:avLst/>
+          </a:prstGeom>
+          <a:noFill/>
+        </p:spPr>
+        <p:txBody>
+          <a:bodyPr wrap="square" anchor="t"/>
+          <a:lstStyle/>
+          <a:p>
+            <a:pPr algn="l"/>
+            <a:r>
+              <a:rPr sz="1700" b="0" i="0" a:ea="Calibri">
+                <a:solidFill>
+                  <a:srgbClr val="CCFBF1"/>
+                </a:solidFill>
+                <a:latin typeface="Calibri"/>
+              </a:rPr>
+              <a:t>Wall, vacuole, chloroplast</a:t>
+            </a:r>
+          </a:p>
+        </p:txBody>
+      </p:sp>
+      <p:sp>
+        <p:nvSpPr>
+          <p:cNvPr id="6" name="Rounded Rectangle 5"/>
+          <p:cNvSpPr/>
+          <p:nvPr/>
+        </p:nvSpPr>
+        <p:spPr>
+          <a:xfrm>
             <a:off x="640080" y="1965960"/>
-            <a:ext cx="10881360" cy="914400"/>
-          </a:xfrm>
-          <a:prstGeom prst="rect">
-            <a:avLst/>
-          </a:prstGeom>
-          <a:noFill/>
-        </p:spPr>
-        <p:txBody>
-          <a:bodyPr wrap="square" anchor="t"/>
-          <a:lstStyle/>
-          <a:p>
-            <a:pPr algn="l"/>
-            <a:r>
-              <a:rPr sz="3400" b="1" i="0" a:ea="Calibri">
-                <a:solidFill>
-                  <a:srgbClr val="FFFFFF"/>
-                </a:solidFill>
-                <a:latin typeface="Calibri"/>
-              </a:rPr>
-              <a:t>Plant cell extras</a:t>
-            </a:r>
-          </a:p>
-        </p:txBody>
-      </p:sp>
-      <p:sp>
-        <p:nvSpPr>
-          <p:cNvPr id="5" name="TextBox 4"/>
-          <p:cNvSpPr txBox="1"/>
-          <p:nvPr/>
-        </p:nvSpPr>
-        <p:spPr>
-          <a:xfrm>
-            <a:off x="640080" y="3154680"/>
-            <a:ext cx="10881360" cy="822960"/>
-          </a:xfrm>
-          <a:prstGeom prst="rect">
-            <a:avLst/>
-          </a:prstGeom>
-          <a:noFill/>
-        </p:spPr>
-        <p:txBody>
-          <a:bodyPr wrap="square" anchor="t"/>
-          <a:lstStyle/>
-          <a:p>
-            <a:pPr algn="l"/>
-            <a:r>
-              <a:rPr sz="1800" b="0" i="0" a:ea="Calibri">
-                <a:solidFill>
-                  <a:srgbClr val="CCFBF1"/>
-                </a:solidFill>
-                <a:latin typeface="Calibri"/>
-              </a:rPr>
-              <a:t>Wall, vacuole, chloroplast</a:t>
-            </a:r>
-          </a:p>
-        </p:txBody>
-      </p:sp>
-      <p:sp>
-        <p:nvSpPr>
-          <p:cNvPr id="6" name="Rectangle 5"/>
-          <p:cNvSpPr/>
-          <p:nvPr/>
-        </p:nvSpPr>
-        <p:spPr>
-          <a:xfrm>
-            <a:off x="0" y="6437376"/>
-            <a:ext cx="12191695" cy="420624"/>
-          </a:xfrm>
-          <a:prstGeom prst="rect">
-            <a:avLst/>
-          </a:prstGeom>
-          <a:solidFill>
-            <a:srgbClr val="004D40"/>
+            <a:ext cx="3520440" cy="3977639"/>
+          </a:xfrm>
+          <a:prstGeom prst="roundRect">
+            <a:avLst/>
+          </a:prstGeom>
+          <a:solidFill>
+            <a:srgbClr val="003D33"/>
           </a:solidFill>
           <a:ln>
             <a:noFill/>
@@ -5490,9 +5490,465 @@
           </a:p>
         </p:txBody>
       </p:sp>
+      <p:sp>
+        <p:nvSpPr>
+          <p:cNvPr id="7" name="Rectangle 6"/>
+          <p:cNvSpPr/>
+          <p:nvPr/>
+        </p:nvSpPr>
+        <p:spPr>
+          <a:xfrm>
+            <a:off x="640080" y="1965960"/>
+            <a:ext cx="3520440" cy="109728"/>
+          </a:xfrm>
+          <a:prstGeom prst="rect">
+            <a:avLst/>
+          </a:prstGeom>
+          <a:solidFill>
+            <a:srgbClr val="009688"/>
+          </a:solidFill>
+          <a:ln>
+            <a:noFill/>
+          </a:ln>
+        </p:spPr>
+        <p:style>
+          <a:lnRef idx="1">
+            <a:schemeClr val="accent1"/>
+          </a:lnRef>
+          <a:fillRef idx="3">
+            <a:schemeClr val="accent1"/>
+          </a:fillRef>
+          <a:effectRef idx="2">
+            <a:schemeClr val="accent1"/>
+          </a:effectRef>
+          <a:fontRef idx="minor">
+            <a:schemeClr val="lt1"/>
+          </a:fontRef>
+        </p:style>
+        <p:txBody>
+          <a:bodyPr rtlCol="0" anchor="ctr"/>
+          <a:lstStyle/>
+          <a:p>
+            <a:pPr algn="ctr"/>
+          </a:p>
+        </p:txBody>
+      </p:sp>
+      <p:sp>
+        <p:nvSpPr>
+          <p:cNvPr id="8" name="TextBox 7"/>
+          <p:cNvSpPr txBox="1"/>
+          <p:nvPr/>
+        </p:nvSpPr>
+        <p:spPr>
+          <a:xfrm>
+            <a:off x="841248" y="2212848"/>
+            <a:ext cx="3108960" cy="457200"/>
+          </a:xfrm>
+          <a:prstGeom prst="rect">
+            <a:avLst/>
+          </a:prstGeom>
+          <a:noFill/>
+        </p:spPr>
+        <p:txBody>
+          <a:bodyPr wrap="square" anchor="t"/>
+          <a:lstStyle/>
+          <a:p>
+            <a:pPr algn="l"/>
+            <a:r>
+              <a:rPr sz="1600" b="1" i="0" a:ea="Calibri">
+                <a:solidFill>
+                  <a:srgbClr val="CCFBF1"/>
+                </a:solidFill>
+                <a:latin typeface="Calibri"/>
+              </a:rPr>
+              <a:t>1   Look for</a:t>
+            </a:r>
+          </a:p>
+        </p:txBody>
+      </p:sp>
+      <p:sp>
+        <p:nvSpPr>
+          <p:cNvPr id="9" name="TextBox 8"/>
+          <p:cNvSpPr txBox="1"/>
+          <p:nvPr/>
+        </p:nvSpPr>
+        <p:spPr>
+          <a:xfrm>
+            <a:off x="841248" y="2788920"/>
+            <a:ext cx="3108960" cy="2880360"/>
+          </a:xfrm>
+          <a:prstGeom prst="rect">
+            <a:avLst/>
+          </a:prstGeom>
+          <a:noFill/>
+        </p:spPr>
+        <p:txBody>
+          <a:bodyPr wrap="square" anchor="t"/>
+          <a:lstStyle/>
+          <a:p>
+            <a:pPr algn="l"/>
+            <a:r>
+              <a:rPr sz="1600" b="0" i="0" a:ea="Calibri">
+                <a:solidFill>
+                  <a:srgbClr val="FFFFFF"/>
+                </a:solidFill>
+                <a:latin typeface="Calibri"/>
+              </a:rPr>
+              <a:t>A cellulose wall, a large permanent vacuole and chloroplasts with grana.</a:t>
+            </a:r>
+          </a:p>
+        </p:txBody>
+      </p:sp>
+      <p:sp>
+        <p:nvSpPr>
+          <p:cNvPr id="10" name="Rounded Rectangle 9"/>
+          <p:cNvSpPr/>
+          <p:nvPr/>
+        </p:nvSpPr>
+        <p:spPr>
+          <a:xfrm>
+            <a:off x="4343400" y="1965960"/>
+            <a:ext cx="3520440" cy="3977639"/>
+          </a:xfrm>
+          <a:prstGeom prst="roundRect">
+            <a:avLst/>
+          </a:prstGeom>
+          <a:solidFill>
+            <a:srgbClr val="003D33"/>
+          </a:solidFill>
+          <a:ln>
+            <a:noFill/>
+          </a:ln>
+        </p:spPr>
+        <p:style>
+          <a:lnRef idx="1">
+            <a:schemeClr val="accent1"/>
+          </a:lnRef>
+          <a:fillRef idx="3">
+            <a:schemeClr val="accent1"/>
+          </a:fillRef>
+          <a:effectRef idx="2">
+            <a:schemeClr val="accent1"/>
+          </a:effectRef>
+          <a:fontRef idx="minor">
+            <a:schemeClr val="lt1"/>
+          </a:fontRef>
+        </p:style>
+        <p:txBody>
+          <a:bodyPr rtlCol="0" anchor="ctr"/>
+          <a:lstStyle/>
+          <a:p>
+            <a:pPr algn="ctr"/>
+          </a:p>
+        </p:txBody>
+      </p:sp>
+      <p:sp>
+        <p:nvSpPr>
+          <p:cNvPr id="11" name="Rectangle 10"/>
+          <p:cNvSpPr/>
+          <p:nvPr/>
+        </p:nvSpPr>
+        <p:spPr>
+          <a:xfrm>
+            <a:off x="4343400" y="1965960"/>
+            <a:ext cx="3520440" cy="109728"/>
+          </a:xfrm>
+          <a:prstGeom prst="rect">
+            <a:avLst/>
+          </a:prstGeom>
+          <a:solidFill>
+            <a:srgbClr val="99F6E4"/>
+          </a:solidFill>
+          <a:ln>
+            <a:noFill/>
+          </a:ln>
+        </p:spPr>
+        <p:style>
+          <a:lnRef idx="1">
+            <a:schemeClr val="accent1"/>
+          </a:lnRef>
+          <a:fillRef idx="3">
+            <a:schemeClr val="accent1"/>
+          </a:fillRef>
+          <a:effectRef idx="2">
+            <a:schemeClr val="accent1"/>
+          </a:effectRef>
+          <a:fontRef idx="minor">
+            <a:schemeClr val="lt1"/>
+          </a:fontRef>
+        </p:style>
+        <p:txBody>
+          <a:bodyPr rtlCol="0" anchor="ctr"/>
+          <a:lstStyle/>
+          <a:p>
+            <a:pPr algn="ctr"/>
+          </a:p>
+        </p:txBody>
+      </p:sp>
+      <p:sp>
+        <p:nvSpPr>
+          <p:cNvPr id="12" name="TextBox 11"/>
+          <p:cNvSpPr txBox="1"/>
+          <p:nvPr/>
+        </p:nvSpPr>
+        <p:spPr>
+          <a:xfrm>
+            <a:off x="4544568" y="2212848"/>
+            <a:ext cx="3108960" cy="457200"/>
+          </a:xfrm>
+          <a:prstGeom prst="rect">
+            <a:avLst/>
+          </a:prstGeom>
+          <a:noFill/>
+        </p:spPr>
+        <p:txBody>
+          <a:bodyPr wrap="square" anchor="t"/>
+          <a:lstStyle/>
+          <a:p>
+            <a:pPr algn="l"/>
+            <a:r>
+              <a:rPr sz="1600" b="1" i="0" a:ea="Calibri">
+                <a:solidFill>
+                  <a:srgbClr val="CCFBF1"/>
+                </a:solidFill>
+                <a:latin typeface="Calibri"/>
+              </a:rPr>
+              <a:t>2   Say in full</a:t>
+            </a:r>
+          </a:p>
+        </p:txBody>
+      </p:sp>
+      <p:sp>
+        <p:nvSpPr>
+          <p:cNvPr id="13" name="TextBox 12"/>
+          <p:cNvSpPr txBox="1"/>
+          <p:nvPr/>
+        </p:nvSpPr>
+        <p:spPr>
+          <a:xfrm>
+            <a:off x="4544568" y="2788920"/>
+            <a:ext cx="3108960" cy="2880360"/>
+          </a:xfrm>
+          <a:prstGeom prst="rect">
+            <a:avLst/>
+          </a:prstGeom>
+          <a:noFill/>
+        </p:spPr>
+        <p:txBody>
+          <a:bodyPr wrap="square" anchor="t"/>
+          <a:lstStyle/>
+          <a:p>
+            <a:pPr algn="l"/>
+            <a:r>
+              <a:rPr sz="1600" b="0" i="0" a:ea="Calibri">
+                <a:solidFill>
+                  <a:srgbClr val="FFFFFF"/>
+                </a:solidFill>
+                <a:latin typeface="Calibri"/>
+              </a:rPr>
+              <a:t>The wall is freely permeable; the membrane controls exchange.</a:t>
+            </a:r>
+          </a:p>
+        </p:txBody>
+      </p:sp>
+      <p:sp>
+        <p:nvSpPr>
+          <p:cNvPr id="14" name="Rounded Rectangle 13"/>
+          <p:cNvSpPr/>
+          <p:nvPr/>
+        </p:nvSpPr>
+        <p:spPr>
+          <a:xfrm>
+            <a:off x="8046720" y="1965960"/>
+            <a:ext cx="3520440" cy="3977639"/>
+          </a:xfrm>
+          <a:prstGeom prst="roundRect">
+            <a:avLst/>
+          </a:prstGeom>
+          <a:solidFill>
+            <a:srgbClr val="003D33"/>
+          </a:solidFill>
+          <a:ln>
+            <a:noFill/>
+          </a:ln>
+        </p:spPr>
+        <p:style>
+          <a:lnRef idx="1">
+            <a:schemeClr val="accent1"/>
+          </a:lnRef>
+          <a:fillRef idx="3">
+            <a:schemeClr val="accent1"/>
+          </a:fillRef>
+          <a:effectRef idx="2">
+            <a:schemeClr val="accent1"/>
+          </a:effectRef>
+          <a:fontRef idx="minor">
+            <a:schemeClr val="lt1"/>
+          </a:fontRef>
+        </p:style>
+        <p:txBody>
+          <a:bodyPr rtlCol="0" anchor="ctr"/>
+          <a:lstStyle/>
+          <a:p>
+            <a:pPr algn="ctr"/>
+          </a:p>
+        </p:txBody>
+      </p:sp>
+      <p:sp>
+        <p:nvSpPr>
+          <p:cNvPr id="15" name="Rectangle 14"/>
+          <p:cNvSpPr/>
+          <p:nvPr/>
+        </p:nvSpPr>
+        <p:spPr>
+          <a:xfrm>
+            <a:off x="8046720" y="1965960"/>
+            <a:ext cx="3520440" cy="109728"/>
+          </a:xfrm>
+          <a:prstGeom prst="rect">
+            <a:avLst/>
+          </a:prstGeom>
+          <a:solidFill>
+            <a:srgbClr val="5EEAD4"/>
+          </a:solidFill>
+          <a:ln>
+            <a:noFill/>
+          </a:ln>
+        </p:spPr>
+        <p:style>
+          <a:lnRef idx="1">
+            <a:schemeClr val="accent1"/>
+          </a:lnRef>
+          <a:fillRef idx="3">
+            <a:schemeClr val="accent1"/>
+          </a:fillRef>
+          <a:effectRef idx="2">
+            <a:schemeClr val="accent1"/>
+          </a:effectRef>
+          <a:fontRef idx="minor">
+            <a:schemeClr val="lt1"/>
+          </a:fontRef>
+        </p:style>
+        <p:txBody>
+          <a:bodyPr rtlCol="0" anchor="ctr"/>
+          <a:lstStyle/>
+          <a:p>
+            <a:pPr algn="ctr"/>
+          </a:p>
+        </p:txBody>
+      </p:sp>
+      <p:sp>
+        <p:nvSpPr>
+          <p:cNvPr id="16" name="TextBox 15"/>
+          <p:cNvSpPr txBox="1"/>
+          <p:nvPr/>
+        </p:nvSpPr>
+        <p:spPr>
+          <a:xfrm>
+            <a:off x="8247888" y="2212848"/>
+            <a:ext cx="3108960" cy="457200"/>
+          </a:xfrm>
+          <a:prstGeom prst="rect">
+            <a:avLst/>
+          </a:prstGeom>
+          <a:noFill/>
+        </p:spPr>
+        <p:txBody>
+          <a:bodyPr wrap="square" anchor="t"/>
+          <a:lstStyle/>
+          <a:p>
+            <a:pPr algn="l"/>
+            <a:r>
+              <a:rPr sz="1600" b="1" i="0" a:ea="Calibri">
+                <a:solidFill>
+                  <a:srgbClr val="CCFBF1"/>
+                </a:solidFill>
+                <a:latin typeface="Calibri"/>
+              </a:rPr>
+              <a:t>3   Level 3 move</a:t>
+            </a:r>
+          </a:p>
+        </p:txBody>
+      </p:sp>
+      <p:sp>
+        <p:nvSpPr>
+          <p:cNvPr id="17" name="TextBox 16"/>
+          <p:cNvSpPr txBox="1"/>
+          <p:nvPr/>
+        </p:nvSpPr>
+        <p:spPr>
+          <a:xfrm>
+            <a:off x="8247888" y="2788920"/>
+            <a:ext cx="3108960" cy="2880360"/>
+          </a:xfrm>
+          <a:prstGeom prst="rect">
+            <a:avLst/>
+          </a:prstGeom>
+          <a:noFill/>
+        </p:spPr>
+        <p:txBody>
+          <a:bodyPr wrap="square" anchor="t"/>
+          <a:lstStyle/>
+          <a:p>
+            <a:pPr algn="l"/>
+            <a:r>
+              <a:rPr sz="1600" b="0" i="0" a:ea="Calibri">
+                <a:solidFill>
+                  <a:srgbClr val="FFFFFF"/>
+                </a:solidFill>
+                <a:latin typeface="Calibri"/>
+              </a:rPr>
+              <a:t>Link each extra structure to support, turgidity or photosynthesis.</a:t>
+            </a:r>
+          </a:p>
+        </p:txBody>
+      </p:sp>
+      <p:sp>
+        <p:nvSpPr>
+          <p:cNvPr id="18" name="Rectangle 17"/>
+          <p:cNvSpPr/>
+          <p:nvPr/>
+        </p:nvSpPr>
+        <p:spPr>
+          <a:xfrm>
+            <a:off x="0" y="6437376"/>
+            <a:ext cx="12191695" cy="420624"/>
+          </a:xfrm>
+          <a:prstGeom prst="rect">
+            <a:avLst/>
+          </a:prstGeom>
+          <a:solidFill>
+            <a:srgbClr val="004D40"/>
+          </a:solidFill>
+          <a:ln>
+            <a:noFill/>
+          </a:ln>
+        </p:spPr>
+        <p:style>
+          <a:lnRef idx="1">
+            <a:schemeClr val="accent1"/>
+          </a:lnRef>
+          <a:fillRef idx="3">
+            <a:schemeClr val="accent1"/>
+          </a:fillRef>
+          <a:effectRef idx="2">
+            <a:schemeClr val="accent1"/>
+          </a:effectRef>
+          <a:fontRef idx="minor">
+            <a:schemeClr val="lt1"/>
+          </a:fontRef>
+        </p:style>
+        <p:txBody>
+          <a:bodyPr rtlCol="0" anchor="ctr"/>
+          <a:lstStyle/>
+          <a:p>
+            <a:pPr algn="ctr"/>
+          </a:p>
+        </p:txBody>
+      </p:sp>
       <p:pic>
         <p:nvPicPr>
-          <p:cNvPr id="7" name="Picture 6" descr="jdscience-footer-logo.png"/>
+          <p:cNvPr id="19" name="Picture 18" descr="jdscience-footer-logo.png"/>
           <p:cNvPicPr>
             <a:picLocks noChangeAspect="1"/>
           </p:cNvPicPr>
@@ -5516,7 +5972,7 @@
       </p:pic>
       <p:sp>
         <p:nvSpPr>
-          <p:cNvPr id="8" name="TextBox 7"/>
+          <p:cNvPr id="20" name="TextBox 19"/>
           <p:cNvSpPr txBox="1"/>
           <p:nvPr/>
         </p:nvSpPr>
@@ -5549,7 +6005,7 @@
       </p:sp>
       <p:sp>
         <p:nvSpPr>
-          <p:cNvPr id="9" name="TextBox 8"/>
+          <p:cNvPr id="21" name="TextBox 20"/>
           <p:cNvSpPr txBox="1"/>
           <p:nvPr/>
         </p:nvSpPr>
@@ -5582,7 +6038,7 @@
       </p:sp>
       <p:sp>
         <p:nvSpPr>
-          <p:cNvPr id="10" name="TextBox 9"/>
+          <p:cNvPr id="22" name="TextBox 21"/>
           <p:cNvSpPr txBox="1"/>
           <p:nvPr/>
         </p:nvSpPr>
@@ -5825,8 +6281,8 @@
         </p:nvSpPr>
         <p:spPr>
           <a:xfrm>
-            <a:off x="6931152" y="1069848"/>
-            <a:ext cx="4617720" cy="685800"/>
+            <a:off x="6931152" y="1051560"/>
+            <a:ext cx="4617720" cy="722376"/>
           </a:xfrm>
           <a:prstGeom prst="rect">
             <a:avLst/>
@@ -5944,8 +6400,8 @@
         </p:nvSpPr>
         <p:spPr>
           <a:xfrm>
-            <a:off x="6931152" y="2029968"/>
-            <a:ext cx="4617720" cy="685800"/>
+            <a:off x="6931152" y="2011680"/>
+            <a:ext cx="4617720" cy="722376"/>
           </a:xfrm>
           <a:prstGeom prst="rect">
             <a:avLst/>
@@ -6063,8 +6519,8 @@
         </p:nvSpPr>
         <p:spPr>
           <a:xfrm>
-            <a:off x="6931152" y="2990088"/>
-            <a:ext cx="4617720" cy="685800"/>
+            <a:off x="6931152" y="2971800"/>
+            <a:ext cx="4617720" cy="722376"/>
           </a:xfrm>
           <a:prstGeom prst="rect">
             <a:avLst/>
@@ -6182,8 +6638,8 @@
         </p:nvSpPr>
         <p:spPr>
           <a:xfrm>
-            <a:off x="6931152" y="3950208"/>
-            <a:ext cx="4617720" cy="685800"/>
+            <a:off x="6931152" y="3931920"/>
+            <a:ext cx="4617720" cy="722376"/>
           </a:xfrm>
           <a:prstGeom prst="rect">
             <a:avLst/>
@@ -6301,8 +6757,8 @@
         </p:nvSpPr>
         <p:spPr>
           <a:xfrm>
-            <a:off x="6931152" y="4910328"/>
-            <a:ext cx="4617720" cy="685800"/>
+            <a:off x="6931152" y="4892040"/>
+            <a:ext cx="4617720" cy="722376"/>
           </a:xfrm>
           <a:prstGeom prst="rect">
             <a:avLst/>
@@ -9620,8 +10076,8 @@
         </p:nvSpPr>
         <p:spPr>
           <a:xfrm>
-            <a:off x="6931152" y="1069848"/>
-            <a:ext cx="4617720" cy="685800"/>
+            <a:off x="6931152" y="1051560"/>
+            <a:ext cx="4617720" cy="722376"/>
           </a:xfrm>
           <a:prstGeom prst="rect">
             <a:avLst/>
@@ -9739,8 +10195,8 @@
         </p:nvSpPr>
         <p:spPr>
           <a:xfrm>
-            <a:off x="6931152" y="2029968"/>
-            <a:ext cx="4617720" cy="685800"/>
+            <a:off x="6931152" y="2011680"/>
+            <a:ext cx="4617720" cy="722376"/>
           </a:xfrm>
           <a:prstGeom prst="rect">
             <a:avLst/>
@@ -9858,8 +10314,8 @@
         </p:nvSpPr>
         <p:spPr>
           <a:xfrm>
-            <a:off x="6931152" y="2990088"/>
-            <a:ext cx="4617720" cy="685800"/>
+            <a:off x="6931152" y="2971800"/>
+            <a:ext cx="4617720" cy="722376"/>
           </a:xfrm>
           <a:prstGeom prst="rect">
             <a:avLst/>
@@ -9977,8 +10433,8 @@
         </p:nvSpPr>
         <p:spPr>
           <a:xfrm>
-            <a:off x="6931152" y="3950208"/>
-            <a:ext cx="4617720" cy="685800"/>
+            <a:off x="6931152" y="3931920"/>
+            <a:ext cx="4617720" cy="722376"/>
           </a:xfrm>
           <a:prstGeom prst="rect">
             <a:avLst/>
@@ -10096,8 +10552,8 @@
         </p:nvSpPr>
         <p:spPr>
           <a:xfrm>
-            <a:off x="6931152" y="4910328"/>
-            <a:ext cx="4617720" cy="685800"/>
+            <a:off x="6931152" y="4892040"/>
+            <a:ext cx="4617720" cy="722376"/>
           </a:xfrm>
           <a:prstGeom prst="rect">
             <a:avLst/>
@@ -14536,7 +14992,7 @@
         <p:spPr>
           <a:xfrm>
             <a:off x="658368" y="2011680"/>
-            <a:ext cx="3249168" cy="3383280"/>
+            <a:ext cx="3249168" cy="1417320"/>
           </a:xfrm>
           <a:prstGeom prst="rect">
             <a:avLst/>
@@ -14562,20 +15018,53 @@
       </p:sp>
       <p:sp>
         <p:nvSpPr>
-          <p:cNvPr id="11" name="Rounded Rectangle 10"/>
+          <p:cNvPr id="11" name="TextBox 10"/>
+          <p:cNvSpPr txBox="1"/>
+          <p:nvPr/>
+        </p:nvSpPr>
+        <p:spPr>
+          <a:xfrm>
+            <a:off x="658368" y="3520440"/>
+            <a:ext cx="3249168" cy="256032"/>
+          </a:xfrm>
+          <a:prstGeom prst="rect">
+            <a:avLst/>
+          </a:prstGeom>
+          <a:noFill/>
+        </p:spPr>
+        <p:txBody>
+          <a:bodyPr wrap="square" anchor="t"/>
+          <a:lstStyle/>
+          <a:p>
+            <a:pPr algn="l"/>
+            <a:r>
+              <a:rPr sz="1100" b="1" i="0" a:ea="Calibri">
+                <a:solidFill>
+                  <a:srgbClr val="475569"/>
+                </a:solidFill>
+                <a:latin typeface="Calibri"/>
+              </a:rPr>
+              <a:t>Write a full-sentence answer</a:t>
+            </a:r>
+          </a:p>
+        </p:txBody>
+      </p:sp>
+      <p:sp>
+        <p:nvSpPr>
+          <p:cNvPr id="12" name="Rectangle 11"/>
           <p:cNvSpPr/>
           <p:nvPr/>
         </p:nvSpPr>
         <p:spPr>
           <a:xfrm>
-            <a:off x="4255008" y="1188720"/>
-            <a:ext cx="3651504" cy="4434840"/>
-          </a:xfrm>
-          <a:prstGeom prst="roundRect">
-            <a:avLst/>
-          </a:prstGeom>
-          <a:solidFill>
-            <a:srgbClr val="FFFFFF"/>
+            <a:off x="658368" y="3858768"/>
+            <a:ext cx="3249168" cy="15875"/>
+          </a:xfrm>
+          <a:prstGeom prst="rect">
+            <a:avLst/>
+          </a:prstGeom>
+          <a:solidFill>
+            <a:srgbClr val="E2E8F0"/>
           </a:solidFill>
           <a:ln>
             <a:noFill/>
@@ -14605,20 +15094,20 @@
       </p:sp>
       <p:sp>
         <p:nvSpPr>
-          <p:cNvPr id="12" name="Rounded Rectangle 11"/>
+          <p:cNvPr id="13" name="Rectangle 12"/>
           <p:cNvSpPr/>
           <p:nvPr/>
         </p:nvSpPr>
         <p:spPr>
           <a:xfrm>
-            <a:off x="4437888" y="1371600"/>
-            <a:ext cx="457200" cy="457200"/>
-          </a:xfrm>
-          <a:prstGeom prst="roundRect">
-            <a:avLst/>
-          </a:prstGeom>
-          <a:solidFill>
-            <a:srgbClr val="9F1239"/>
+            <a:off x="658368" y="4151376"/>
+            <a:ext cx="3249168" cy="15875"/>
+          </a:xfrm>
+          <a:prstGeom prst="rect">
+            <a:avLst/>
+          </a:prstGeom>
+          <a:solidFill>
+            <a:srgbClr val="E2E8F0"/>
           </a:solidFill>
           <a:ln>
             <a:noFill/>
@@ -14648,119 +15137,20 @@
       </p:sp>
       <p:sp>
         <p:nvSpPr>
-          <p:cNvPr id="13" name="TextBox 12"/>
-          <p:cNvSpPr txBox="1"/>
-          <p:nvPr/>
-        </p:nvSpPr>
-        <p:spPr>
-          <a:xfrm>
-            <a:off x="4437888" y="1426464"/>
-            <a:ext cx="457200" cy="365760"/>
-          </a:xfrm>
-          <a:prstGeom prst="rect">
-            <a:avLst/>
-          </a:prstGeom>
-          <a:noFill/>
-        </p:spPr>
-        <p:txBody>
-          <a:bodyPr wrap="square" anchor="t"/>
-          <a:lstStyle/>
-          <a:p>
-            <a:pPr algn="ctr"/>
-            <a:r>
-              <a:rPr sz="1600" b="1" i="0" a:ea="Calibri">
-                <a:solidFill>
-                  <a:srgbClr val="FFFFFF"/>
-                </a:solidFill>
-                <a:latin typeface="Calibri"/>
-              </a:rPr>
-              <a:t>2</a:t>
-            </a:r>
-          </a:p>
-        </p:txBody>
-      </p:sp>
-      <p:sp>
-        <p:nvSpPr>
-          <p:cNvPr id="14" name="TextBox 13"/>
-          <p:cNvSpPr txBox="1"/>
-          <p:nvPr/>
-        </p:nvSpPr>
-        <p:spPr>
-          <a:xfrm>
-            <a:off x="4986528" y="1426464"/>
-            <a:ext cx="2645664" cy="365760"/>
-          </a:xfrm>
-          <a:prstGeom prst="rect">
-            <a:avLst/>
-          </a:prstGeom>
-          <a:noFill/>
-        </p:spPr>
-        <p:txBody>
-          <a:bodyPr wrap="square" anchor="t"/>
-          <a:lstStyle/>
-          <a:p>
-            <a:pPr algn="l"/>
-            <a:r>
-              <a:rPr sz="1300" b="1" i="0" a:ea="Calibri">
-                <a:solidFill>
-                  <a:srgbClr val="9F1239"/>
-                </a:solidFill>
-                <a:latin typeface="Calibri"/>
-              </a:rPr>
-              <a:t>4 marks</a:t>
-            </a:r>
-          </a:p>
-        </p:txBody>
-      </p:sp>
-      <p:sp>
-        <p:nvSpPr>
-          <p:cNvPr id="15" name="TextBox 14"/>
-          <p:cNvSpPr txBox="1"/>
-          <p:nvPr/>
-        </p:nvSpPr>
-        <p:spPr>
-          <a:xfrm>
-            <a:off x="4456176" y="2011680"/>
-            <a:ext cx="3249168" cy="3383280"/>
-          </a:xfrm>
-          <a:prstGeom prst="rect">
-            <a:avLst/>
-          </a:prstGeom>
-          <a:noFill/>
-        </p:spPr>
-        <p:txBody>
-          <a:bodyPr wrap="square" anchor="t"/>
-          <a:lstStyle/>
-          <a:p>
-            <a:pPr algn="l"/>
-            <a:r>
-              <a:rPr sz="1600" b="0" i="0" a:ea="Calibri">
-                <a:solidFill>
-                  <a:srgbClr val="0F172A"/>
-                </a:solidFill>
-                <a:latin typeface="Calibri"/>
-              </a:rPr>
-              <a:t>Explain two ways a palisade mesophyll cell is adapted for photosynthesis.</a:t>
-            </a:r>
-          </a:p>
-        </p:txBody>
-      </p:sp>
-      <p:sp>
-        <p:nvSpPr>
-          <p:cNvPr id="16" name="Rounded Rectangle 15"/>
+          <p:cNvPr id="14" name="Rectangle 13"/>
           <p:cNvSpPr/>
           <p:nvPr/>
         </p:nvSpPr>
         <p:spPr>
           <a:xfrm>
-            <a:off x="8052816" y="1188720"/>
-            <a:ext cx="3651504" cy="4434840"/>
-          </a:xfrm>
-          <a:prstGeom prst="roundRect">
-            <a:avLst/>
-          </a:prstGeom>
-          <a:solidFill>
-            <a:srgbClr val="FFFFFF"/>
+            <a:off x="658368" y="4443984"/>
+            <a:ext cx="3249168" cy="15875"/>
+          </a:xfrm>
+          <a:prstGeom prst="rect">
+            <a:avLst/>
+          </a:prstGeom>
+          <a:solidFill>
+            <a:srgbClr val="E2E8F0"/>
           </a:solidFill>
           <a:ln>
             <a:noFill/>
@@ -14790,20 +15180,20 @@
       </p:sp>
       <p:sp>
         <p:nvSpPr>
-          <p:cNvPr id="17" name="Rounded Rectangle 16"/>
+          <p:cNvPr id="15" name="Rectangle 14"/>
           <p:cNvSpPr/>
           <p:nvPr/>
         </p:nvSpPr>
         <p:spPr>
           <a:xfrm>
-            <a:off x="8235696" y="1371600"/>
-            <a:ext cx="457200" cy="457200"/>
-          </a:xfrm>
-          <a:prstGeom prst="roundRect">
-            <a:avLst/>
-          </a:prstGeom>
-          <a:solidFill>
-            <a:srgbClr val="9F1239"/>
+            <a:off x="658368" y="4736592"/>
+            <a:ext cx="3249168" cy="15875"/>
+          </a:xfrm>
+          <a:prstGeom prst="rect">
+            <a:avLst/>
+          </a:prstGeom>
+          <a:solidFill>
+            <a:srgbClr val="E2E8F0"/>
           </a:solidFill>
           <a:ln>
             <a:noFill/>
@@ -14833,152 +15223,20 @@
       </p:sp>
       <p:sp>
         <p:nvSpPr>
-          <p:cNvPr id="18" name="TextBox 17"/>
-          <p:cNvSpPr txBox="1"/>
-          <p:nvPr/>
-        </p:nvSpPr>
-        <p:spPr>
-          <a:xfrm>
-            <a:off x="8235696" y="1426464"/>
-            <a:ext cx="457200" cy="365760"/>
-          </a:xfrm>
-          <a:prstGeom prst="rect">
-            <a:avLst/>
-          </a:prstGeom>
-          <a:noFill/>
-        </p:spPr>
-        <p:txBody>
-          <a:bodyPr wrap="square" anchor="t"/>
-          <a:lstStyle/>
-          <a:p>
-            <a:pPr algn="ctr"/>
-            <a:r>
-              <a:rPr sz="1600" b="1" i="0" a:ea="Calibri">
-                <a:solidFill>
-                  <a:srgbClr val="FFFFFF"/>
-                </a:solidFill>
-                <a:latin typeface="Calibri"/>
-              </a:rPr>
-              <a:t>3</a:t>
-            </a:r>
-          </a:p>
-        </p:txBody>
-      </p:sp>
-      <p:sp>
-        <p:nvSpPr>
-          <p:cNvPr id="19" name="TextBox 18"/>
-          <p:cNvSpPr txBox="1"/>
-          <p:nvPr/>
-        </p:nvSpPr>
-        <p:spPr>
-          <a:xfrm>
-            <a:off x="8784336" y="1426464"/>
-            <a:ext cx="2645664" cy="365760"/>
-          </a:xfrm>
-          <a:prstGeom prst="rect">
-            <a:avLst/>
-          </a:prstGeom>
-          <a:noFill/>
-        </p:spPr>
-        <p:txBody>
-          <a:bodyPr wrap="square" anchor="t"/>
-          <a:lstStyle/>
-          <a:p>
-            <a:pPr algn="l"/>
-            <a:r>
-              <a:rPr sz="1300" b="1" i="0" a:ea="Calibri">
-                <a:solidFill>
-                  <a:srgbClr val="9F1239"/>
-                </a:solidFill>
-                <a:latin typeface="Calibri"/>
-              </a:rPr>
-              <a:t>3 marks</a:t>
-            </a:r>
-          </a:p>
-        </p:txBody>
-      </p:sp>
-      <p:sp>
-        <p:nvSpPr>
-          <p:cNvPr id="20" name="TextBox 19"/>
-          <p:cNvSpPr txBox="1"/>
-          <p:nvPr/>
-        </p:nvSpPr>
-        <p:spPr>
-          <a:xfrm>
-            <a:off x="8253984" y="2011680"/>
-            <a:ext cx="3249168" cy="3383280"/>
-          </a:xfrm>
-          <a:prstGeom prst="rect">
-            <a:avLst/>
-          </a:prstGeom>
-          <a:noFill/>
-        </p:spPr>
-        <p:txBody>
-          <a:bodyPr wrap="square" anchor="t"/>
-          <a:lstStyle/>
-          <a:p>
-            <a:pPr algn="l"/>
-            <a:r>
-              <a:rPr sz="1600" b="0" i="0" a:ea="Calibri">
-                <a:solidFill>
-                  <a:srgbClr val="0F172A"/>
-                </a:solidFill>
-                <a:latin typeface="Calibri"/>
-              </a:rPr>
-              <a:t>A student says the cell wall and the cell membrane are the same structure. Correct this statement.</a:t>
-            </a:r>
-          </a:p>
-        </p:txBody>
-      </p:sp>
-      <p:sp>
-        <p:nvSpPr>
-          <p:cNvPr id="21" name="TextBox 20"/>
-          <p:cNvSpPr txBox="1"/>
-          <p:nvPr/>
-        </p:nvSpPr>
-        <p:spPr>
-          <a:xfrm>
-            <a:off x="457200" y="5742432"/>
-            <a:ext cx="11247120" cy="274320"/>
-          </a:xfrm>
-          <a:prstGeom prst="rect">
-            <a:avLst/>
-          </a:prstGeom>
-          <a:noFill/>
-        </p:spPr>
-        <p:txBody>
-          <a:bodyPr wrap="square" anchor="t"/>
-          <a:lstStyle/>
-          <a:p>
-            <a:pPr algn="l"/>
-            <a:r>
-              <a:rPr sz="1300" b="1" i="0" a:ea="Calibri">
-                <a:solidFill>
-                  <a:srgbClr val="9F1239"/>
-                </a:solidFill>
-                <a:latin typeface="Calibri"/>
-              </a:rPr>
-              <a:t>Think first — answers are on the next slide.</a:t>
-            </a:r>
-          </a:p>
-        </p:txBody>
-      </p:sp>
-      <p:sp>
-        <p:nvSpPr>
-          <p:cNvPr id="22" name="Rectangle 21"/>
+          <p:cNvPr id="16" name="Rounded Rectangle 15"/>
           <p:cNvSpPr/>
           <p:nvPr/>
         </p:nvSpPr>
         <p:spPr>
           <a:xfrm>
-            <a:off x="0" y="6437376"/>
-            <a:ext cx="12191695" cy="420624"/>
-          </a:xfrm>
-          <a:prstGeom prst="rect">
-            <a:avLst/>
-          </a:prstGeom>
-          <a:solidFill>
-            <a:srgbClr val="004D40"/>
+            <a:off x="4255008" y="1188720"/>
+            <a:ext cx="3651504" cy="4434840"/>
+          </a:xfrm>
+          <a:prstGeom prst="roundRect">
+            <a:avLst/>
+          </a:prstGeom>
+          <a:solidFill>
+            <a:srgbClr val="FFFFFF"/>
           </a:solidFill>
           <a:ln>
             <a:noFill/>
@@ -15006,9 +15264,822 @@
           </a:p>
         </p:txBody>
       </p:sp>
+      <p:sp>
+        <p:nvSpPr>
+          <p:cNvPr id="17" name="Rounded Rectangle 16"/>
+          <p:cNvSpPr/>
+          <p:nvPr/>
+        </p:nvSpPr>
+        <p:spPr>
+          <a:xfrm>
+            <a:off x="4437888" y="1371600"/>
+            <a:ext cx="457200" cy="457200"/>
+          </a:xfrm>
+          <a:prstGeom prst="roundRect">
+            <a:avLst/>
+          </a:prstGeom>
+          <a:solidFill>
+            <a:srgbClr val="9F1239"/>
+          </a:solidFill>
+          <a:ln>
+            <a:noFill/>
+          </a:ln>
+        </p:spPr>
+        <p:style>
+          <a:lnRef idx="1">
+            <a:schemeClr val="accent1"/>
+          </a:lnRef>
+          <a:fillRef idx="3">
+            <a:schemeClr val="accent1"/>
+          </a:fillRef>
+          <a:effectRef idx="2">
+            <a:schemeClr val="accent1"/>
+          </a:effectRef>
+          <a:fontRef idx="minor">
+            <a:schemeClr val="lt1"/>
+          </a:fontRef>
+        </p:style>
+        <p:txBody>
+          <a:bodyPr rtlCol="0" anchor="ctr"/>
+          <a:lstStyle/>
+          <a:p>
+            <a:pPr algn="ctr"/>
+          </a:p>
+        </p:txBody>
+      </p:sp>
+      <p:sp>
+        <p:nvSpPr>
+          <p:cNvPr id="18" name="TextBox 17"/>
+          <p:cNvSpPr txBox="1"/>
+          <p:nvPr/>
+        </p:nvSpPr>
+        <p:spPr>
+          <a:xfrm>
+            <a:off x="4437888" y="1426464"/>
+            <a:ext cx="457200" cy="365760"/>
+          </a:xfrm>
+          <a:prstGeom prst="rect">
+            <a:avLst/>
+          </a:prstGeom>
+          <a:noFill/>
+        </p:spPr>
+        <p:txBody>
+          <a:bodyPr wrap="square" anchor="t"/>
+          <a:lstStyle/>
+          <a:p>
+            <a:pPr algn="ctr"/>
+            <a:r>
+              <a:rPr sz="1600" b="1" i="0" a:ea="Calibri">
+                <a:solidFill>
+                  <a:srgbClr val="FFFFFF"/>
+                </a:solidFill>
+                <a:latin typeface="Calibri"/>
+              </a:rPr>
+              <a:t>2</a:t>
+            </a:r>
+          </a:p>
+        </p:txBody>
+      </p:sp>
+      <p:sp>
+        <p:nvSpPr>
+          <p:cNvPr id="19" name="TextBox 18"/>
+          <p:cNvSpPr txBox="1"/>
+          <p:nvPr/>
+        </p:nvSpPr>
+        <p:spPr>
+          <a:xfrm>
+            <a:off x="4986528" y="1426464"/>
+            <a:ext cx="2645664" cy="365760"/>
+          </a:xfrm>
+          <a:prstGeom prst="rect">
+            <a:avLst/>
+          </a:prstGeom>
+          <a:noFill/>
+        </p:spPr>
+        <p:txBody>
+          <a:bodyPr wrap="square" anchor="t"/>
+          <a:lstStyle/>
+          <a:p>
+            <a:pPr algn="l"/>
+            <a:r>
+              <a:rPr sz="1300" b="1" i="0" a:ea="Calibri">
+                <a:solidFill>
+                  <a:srgbClr val="9F1239"/>
+                </a:solidFill>
+                <a:latin typeface="Calibri"/>
+              </a:rPr>
+              <a:t>4 marks</a:t>
+            </a:r>
+          </a:p>
+        </p:txBody>
+      </p:sp>
+      <p:sp>
+        <p:nvSpPr>
+          <p:cNvPr id="20" name="TextBox 19"/>
+          <p:cNvSpPr txBox="1"/>
+          <p:nvPr/>
+        </p:nvSpPr>
+        <p:spPr>
+          <a:xfrm>
+            <a:off x="4456176" y="2011680"/>
+            <a:ext cx="3249168" cy="1417320"/>
+          </a:xfrm>
+          <a:prstGeom prst="rect">
+            <a:avLst/>
+          </a:prstGeom>
+          <a:noFill/>
+        </p:spPr>
+        <p:txBody>
+          <a:bodyPr wrap="square" anchor="t"/>
+          <a:lstStyle/>
+          <a:p>
+            <a:pPr algn="l"/>
+            <a:r>
+              <a:rPr sz="1600" b="0" i="0" a:ea="Calibri">
+                <a:solidFill>
+                  <a:srgbClr val="0F172A"/>
+                </a:solidFill>
+                <a:latin typeface="Calibri"/>
+              </a:rPr>
+              <a:t>Explain two ways a palisade mesophyll cell is adapted for photosynthesis.</a:t>
+            </a:r>
+          </a:p>
+        </p:txBody>
+      </p:sp>
+      <p:sp>
+        <p:nvSpPr>
+          <p:cNvPr id="21" name="TextBox 20"/>
+          <p:cNvSpPr txBox="1"/>
+          <p:nvPr/>
+        </p:nvSpPr>
+        <p:spPr>
+          <a:xfrm>
+            <a:off x="4456176" y="3520440"/>
+            <a:ext cx="3249168" cy="256032"/>
+          </a:xfrm>
+          <a:prstGeom prst="rect">
+            <a:avLst/>
+          </a:prstGeom>
+          <a:noFill/>
+        </p:spPr>
+        <p:txBody>
+          <a:bodyPr wrap="square" anchor="t"/>
+          <a:lstStyle/>
+          <a:p>
+            <a:pPr algn="l"/>
+            <a:r>
+              <a:rPr sz="1100" b="1" i="0" a:ea="Calibri">
+                <a:solidFill>
+                  <a:srgbClr val="475569"/>
+                </a:solidFill>
+                <a:latin typeface="Calibri"/>
+              </a:rPr>
+              <a:t>Write a full-sentence answer</a:t>
+            </a:r>
+          </a:p>
+        </p:txBody>
+      </p:sp>
+      <p:sp>
+        <p:nvSpPr>
+          <p:cNvPr id="22" name="Rectangle 21"/>
+          <p:cNvSpPr/>
+          <p:nvPr/>
+        </p:nvSpPr>
+        <p:spPr>
+          <a:xfrm>
+            <a:off x="4456176" y="3858768"/>
+            <a:ext cx="3249168" cy="15875"/>
+          </a:xfrm>
+          <a:prstGeom prst="rect">
+            <a:avLst/>
+          </a:prstGeom>
+          <a:solidFill>
+            <a:srgbClr val="E2E8F0"/>
+          </a:solidFill>
+          <a:ln>
+            <a:noFill/>
+          </a:ln>
+        </p:spPr>
+        <p:style>
+          <a:lnRef idx="1">
+            <a:schemeClr val="accent1"/>
+          </a:lnRef>
+          <a:fillRef idx="3">
+            <a:schemeClr val="accent1"/>
+          </a:fillRef>
+          <a:effectRef idx="2">
+            <a:schemeClr val="accent1"/>
+          </a:effectRef>
+          <a:fontRef idx="minor">
+            <a:schemeClr val="lt1"/>
+          </a:fontRef>
+        </p:style>
+        <p:txBody>
+          <a:bodyPr rtlCol="0" anchor="ctr"/>
+          <a:lstStyle/>
+          <a:p>
+            <a:pPr algn="ctr"/>
+          </a:p>
+        </p:txBody>
+      </p:sp>
+      <p:sp>
+        <p:nvSpPr>
+          <p:cNvPr id="23" name="Rectangle 22"/>
+          <p:cNvSpPr/>
+          <p:nvPr/>
+        </p:nvSpPr>
+        <p:spPr>
+          <a:xfrm>
+            <a:off x="4456176" y="4151376"/>
+            <a:ext cx="3249168" cy="15875"/>
+          </a:xfrm>
+          <a:prstGeom prst="rect">
+            <a:avLst/>
+          </a:prstGeom>
+          <a:solidFill>
+            <a:srgbClr val="E2E8F0"/>
+          </a:solidFill>
+          <a:ln>
+            <a:noFill/>
+          </a:ln>
+        </p:spPr>
+        <p:style>
+          <a:lnRef idx="1">
+            <a:schemeClr val="accent1"/>
+          </a:lnRef>
+          <a:fillRef idx="3">
+            <a:schemeClr val="accent1"/>
+          </a:fillRef>
+          <a:effectRef idx="2">
+            <a:schemeClr val="accent1"/>
+          </a:effectRef>
+          <a:fontRef idx="minor">
+            <a:schemeClr val="lt1"/>
+          </a:fontRef>
+        </p:style>
+        <p:txBody>
+          <a:bodyPr rtlCol="0" anchor="ctr"/>
+          <a:lstStyle/>
+          <a:p>
+            <a:pPr algn="ctr"/>
+          </a:p>
+        </p:txBody>
+      </p:sp>
+      <p:sp>
+        <p:nvSpPr>
+          <p:cNvPr id="24" name="Rectangle 23"/>
+          <p:cNvSpPr/>
+          <p:nvPr/>
+        </p:nvSpPr>
+        <p:spPr>
+          <a:xfrm>
+            <a:off x="4456176" y="4443984"/>
+            <a:ext cx="3249168" cy="15875"/>
+          </a:xfrm>
+          <a:prstGeom prst="rect">
+            <a:avLst/>
+          </a:prstGeom>
+          <a:solidFill>
+            <a:srgbClr val="E2E8F0"/>
+          </a:solidFill>
+          <a:ln>
+            <a:noFill/>
+          </a:ln>
+        </p:spPr>
+        <p:style>
+          <a:lnRef idx="1">
+            <a:schemeClr val="accent1"/>
+          </a:lnRef>
+          <a:fillRef idx="3">
+            <a:schemeClr val="accent1"/>
+          </a:fillRef>
+          <a:effectRef idx="2">
+            <a:schemeClr val="accent1"/>
+          </a:effectRef>
+          <a:fontRef idx="minor">
+            <a:schemeClr val="lt1"/>
+          </a:fontRef>
+        </p:style>
+        <p:txBody>
+          <a:bodyPr rtlCol="0" anchor="ctr"/>
+          <a:lstStyle/>
+          <a:p>
+            <a:pPr algn="ctr"/>
+          </a:p>
+        </p:txBody>
+      </p:sp>
+      <p:sp>
+        <p:nvSpPr>
+          <p:cNvPr id="25" name="Rectangle 24"/>
+          <p:cNvSpPr/>
+          <p:nvPr/>
+        </p:nvSpPr>
+        <p:spPr>
+          <a:xfrm>
+            <a:off x="4456176" y="4736592"/>
+            <a:ext cx="3249168" cy="15875"/>
+          </a:xfrm>
+          <a:prstGeom prst="rect">
+            <a:avLst/>
+          </a:prstGeom>
+          <a:solidFill>
+            <a:srgbClr val="E2E8F0"/>
+          </a:solidFill>
+          <a:ln>
+            <a:noFill/>
+          </a:ln>
+        </p:spPr>
+        <p:style>
+          <a:lnRef idx="1">
+            <a:schemeClr val="accent1"/>
+          </a:lnRef>
+          <a:fillRef idx="3">
+            <a:schemeClr val="accent1"/>
+          </a:fillRef>
+          <a:effectRef idx="2">
+            <a:schemeClr val="accent1"/>
+          </a:effectRef>
+          <a:fontRef idx="minor">
+            <a:schemeClr val="lt1"/>
+          </a:fontRef>
+        </p:style>
+        <p:txBody>
+          <a:bodyPr rtlCol="0" anchor="ctr"/>
+          <a:lstStyle/>
+          <a:p>
+            <a:pPr algn="ctr"/>
+          </a:p>
+        </p:txBody>
+      </p:sp>
+      <p:sp>
+        <p:nvSpPr>
+          <p:cNvPr id="26" name="Rounded Rectangle 25"/>
+          <p:cNvSpPr/>
+          <p:nvPr/>
+        </p:nvSpPr>
+        <p:spPr>
+          <a:xfrm>
+            <a:off x="8052816" y="1188720"/>
+            <a:ext cx="3651504" cy="4434840"/>
+          </a:xfrm>
+          <a:prstGeom prst="roundRect">
+            <a:avLst/>
+          </a:prstGeom>
+          <a:solidFill>
+            <a:srgbClr val="FFFFFF"/>
+          </a:solidFill>
+          <a:ln>
+            <a:noFill/>
+          </a:ln>
+        </p:spPr>
+        <p:style>
+          <a:lnRef idx="1">
+            <a:schemeClr val="accent1"/>
+          </a:lnRef>
+          <a:fillRef idx="3">
+            <a:schemeClr val="accent1"/>
+          </a:fillRef>
+          <a:effectRef idx="2">
+            <a:schemeClr val="accent1"/>
+          </a:effectRef>
+          <a:fontRef idx="minor">
+            <a:schemeClr val="lt1"/>
+          </a:fontRef>
+        </p:style>
+        <p:txBody>
+          <a:bodyPr rtlCol="0" anchor="ctr"/>
+          <a:lstStyle/>
+          <a:p>
+            <a:pPr algn="ctr"/>
+          </a:p>
+        </p:txBody>
+      </p:sp>
+      <p:sp>
+        <p:nvSpPr>
+          <p:cNvPr id="27" name="Rounded Rectangle 26"/>
+          <p:cNvSpPr/>
+          <p:nvPr/>
+        </p:nvSpPr>
+        <p:spPr>
+          <a:xfrm>
+            <a:off x="8235696" y="1371600"/>
+            <a:ext cx="457200" cy="457200"/>
+          </a:xfrm>
+          <a:prstGeom prst="roundRect">
+            <a:avLst/>
+          </a:prstGeom>
+          <a:solidFill>
+            <a:srgbClr val="9F1239"/>
+          </a:solidFill>
+          <a:ln>
+            <a:noFill/>
+          </a:ln>
+        </p:spPr>
+        <p:style>
+          <a:lnRef idx="1">
+            <a:schemeClr val="accent1"/>
+          </a:lnRef>
+          <a:fillRef idx="3">
+            <a:schemeClr val="accent1"/>
+          </a:fillRef>
+          <a:effectRef idx="2">
+            <a:schemeClr val="accent1"/>
+          </a:effectRef>
+          <a:fontRef idx="minor">
+            <a:schemeClr val="lt1"/>
+          </a:fontRef>
+        </p:style>
+        <p:txBody>
+          <a:bodyPr rtlCol="0" anchor="ctr"/>
+          <a:lstStyle/>
+          <a:p>
+            <a:pPr algn="ctr"/>
+          </a:p>
+        </p:txBody>
+      </p:sp>
+      <p:sp>
+        <p:nvSpPr>
+          <p:cNvPr id="28" name="TextBox 27"/>
+          <p:cNvSpPr txBox="1"/>
+          <p:nvPr/>
+        </p:nvSpPr>
+        <p:spPr>
+          <a:xfrm>
+            <a:off x="8235696" y="1426464"/>
+            <a:ext cx="457200" cy="365760"/>
+          </a:xfrm>
+          <a:prstGeom prst="rect">
+            <a:avLst/>
+          </a:prstGeom>
+          <a:noFill/>
+        </p:spPr>
+        <p:txBody>
+          <a:bodyPr wrap="square" anchor="t"/>
+          <a:lstStyle/>
+          <a:p>
+            <a:pPr algn="ctr"/>
+            <a:r>
+              <a:rPr sz="1600" b="1" i="0" a:ea="Calibri">
+                <a:solidFill>
+                  <a:srgbClr val="FFFFFF"/>
+                </a:solidFill>
+                <a:latin typeface="Calibri"/>
+              </a:rPr>
+              <a:t>3</a:t>
+            </a:r>
+          </a:p>
+        </p:txBody>
+      </p:sp>
+      <p:sp>
+        <p:nvSpPr>
+          <p:cNvPr id="29" name="TextBox 28"/>
+          <p:cNvSpPr txBox="1"/>
+          <p:nvPr/>
+        </p:nvSpPr>
+        <p:spPr>
+          <a:xfrm>
+            <a:off x="8784336" y="1426464"/>
+            <a:ext cx="2645664" cy="365760"/>
+          </a:xfrm>
+          <a:prstGeom prst="rect">
+            <a:avLst/>
+          </a:prstGeom>
+          <a:noFill/>
+        </p:spPr>
+        <p:txBody>
+          <a:bodyPr wrap="square" anchor="t"/>
+          <a:lstStyle/>
+          <a:p>
+            <a:pPr algn="l"/>
+            <a:r>
+              <a:rPr sz="1300" b="1" i="0" a:ea="Calibri">
+                <a:solidFill>
+                  <a:srgbClr val="9F1239"/>
+                </a:solidFill>
+                <a:latin typeface="Calibri"/>
+              </a:rPr>
+              <a:t>3 marks</a:t>
+            </a:r>
+          </a:p>
+        </p:txBody>
+      </p:sp>
+      <p:sp>
+        <p:nvSpPr>
+          <p:cNvPr id="30" name="TextBox 29"/>
+          <p:cNvSpPr txBox="1"/>
+          <p:nvPr/>
+        </p:nvSpPr>
+        <p:spPr>
+          <a:xfrm>
+            <a:off x="8253984" y="2011680"/>
+            <a:ext cx="3249168" cy="1417320"/>
+          </a:xfrm>
+          <a:prstGeom prst="rect">
+            <a:avLst/>
+          </a:prstGeom>
+          <a:noFill/>
+        </p:spPr>
+        <p:txBody>
+          <a:bodyPr wrap="square" anchor="t"/>
+          <a:lstStyle/>
+          <a:p>
+            <a:pPr algn="l"/>
+            <a:r>
+              <a:rPr sz="1600" b="0" i="0" a:ea="Calibri">
+                <a:solidFill>
+                  <a:srgbClr val="0F172A"/>
+                </a:solidFill>
+                <a:latin typeface="Calibri"/>
+              </a:rPr>
+              <a:t>A student says the cell wall and the cell membrane are the same structure. Correct this statement.</a:t>
+            </a:r>
+          </a:p>
+        </p:txBody>
+      </p:sp>
+      <p:sp>
+        <p:nvSpPr>
+          <p:cNvPr id="31" name="TextBox 30"/>
+          <p:cNvSpPr txBox="1"/>
+          <p:nvPr/>
+        </p:nvSpPr>
+        <p:spPr>
+          <a:xfrm>
+            <a:off x="8253984" y="3520440"/>
+            <a:ext cx="3249168" cy="256032"/>
+          </a:xfrm>
+          <a:prstGeom prst="rect">
+            <a:avLst/>
+          </a:prstGeom>
+          <a:noFill/>
+        </p:spPr>
+        <p:txBody>
+          <a:bodyPr wrap="square" anchor="t"/>
+          <a:lstStyle/>
+          <a:p>
+            <a:pPr algn="l"/>
+            <a:r>
+              <a:rPr sz="1100" b="1" i="0" a:ea="Calibri">
+                <a:solidFill>
+                  <a:srgbClr val="475569"/>
+                </a:solidFill>
+                <a:latin typeface="Calibri"/>
+              </a:rPr>
+              <a:t>Write a full-sentence answer</a:t>
+            </a:r>
+          </a:p>
+        </p:txBody>
+      </p:sp>
+      <p:sp>
+        <p:nvSpPr>
+          <p:cNvPr id="32" name="Rectangle 31"/>
+          <p:cNvSpPr/>
+          <p:nvPr/>
+        </p:nvSpPr>
+        <p:spPr>
+          <a:xfrm>
+            <a:off x="8253984" y="3858768"/>
+            <a:ext cx="3249168" cy="15875"/>
+          </a:xfrm>
+          <a:prstGeom prst="rect">
+            <a:avLst/>
+          </a:prstGeom>
+          <a:solidFill>
+            <a:srgbClr val="E2E8F0"/>
+          </a:solidFill>
+          <a:ln>
+            <a:noFill/>
+          </a:ln>
+        </p:spPr>
+        <p:style>
+          <a:lnRef idx="1">
+            <a:schemeClr val="accent1"/>
+          </a:lnRef>
+          <a:fillRef idx="3">
+            <a:schemeClr val="accent1"/>
+          </a:fillRef>
+          <a:effectRef idx="2">
+            <a:schemeClr val="accent1"/>
+          </a:effectRef>
+          <a:fontRef idx="minor">
+            <a:schemeClr val="lt1"/>
+          </a:fontRef>
+        </p:style>
+        <p:txBody>
+          <a:bodyPr rtlCol="0" anchor="ctr"/>
+          <a:lstStyle/>
+          <a:p>
+            <a:pPr algn="ctr"/>
+          </a:p>
+        </p:txBody>
+      </p:sp>
+      <p:sp>
+        <p:nvSpPr>
+          <p:cNvPr id="33" name="Rectangle 32"/>
+          <p:cNvSpPr/>
+          <p:nvPr/>
+        </p:nvSpPr>
+        <p:spPr>
+          <a:xfrm>
+            <a:off x="8253984" y="4151376"/>
+            <a:ext cx="3249168" cy="15875"/>
+          </a:xfrm>
+          <a:prstGeom prst="rect">
+            <a:avLst/>
+          </a:prstGeom>
+          <a:solidFill>
+            <a:srgbClr val="E2E8F0"/>
+          </a:solidFill>
+          <a:ln>
+            <a:noFill/>
+          </a:ln>
+        </p:spPr>
+        <p:style>
+          <a:lnRef idx="1">
+            <a:schemeClr val="accent1"/>
+          </a:lnRef>
+          <a:fillRef idx="3">
+            <a:schemeClr val="accent1"/>
+          </a:fillRef>
+          <a:effectRef idx="2">
+            <a:schemeClr val="accent1"/>
+          </a:effectRef>
+          <a:fontRef idx="minor">
+            <a:schemeClr val="lt1"/>
+          </a:fontRef>
+        </p:style>
+        <p:txBody>
+          <a:bodyPr rtlCol="0" anchor="ctr"/>
+          <a:lstStyle/>
+          <a:p>
+            <a:pPr algn="ctr"/>
+          </a:p>
+        </p:txBody>
+      </p:sp>
+      <p:sp>
+        <p:nvSpPr>
+          <p:cNvPr id="34" name="Rectangle 33"/>
+          <p:cNvSpPr/>
+          <p:nvPr/>
+        </p:nvSpPr>
+        <p:spPr>
+          <a:xfrm>
+            <a:off x="8253984" y="4443984"/>
+            <a:ext cx="3249168" cy="15875"/>
+          </a:xfrm>
+          <a:prstGeom prst="rect">
+            <a:avLst/>
+          </a:prstGeom>
+          <a:solidFill>
+            <a:srgbClr val="E2E8F0"/>
+          </a:solidFill>
+          <a:ln>
+            <a:noFill/>
+          </a:ln>
+        </p:spPr>
+        <p:style>
+          <a:lnRef idx="1">
+            <a:schemeClr val="accent1"/>
+          </a:lnRef>
+          <a:fillRef idx="3">
+            <a:schemeClr val="accent1"/>
+          </a:fillRef>
+          <a:effectRef idx="2">
+            <a:schemeClr val="accent1"/>
+          </a:effectRef>
+          <a:fontRef idx="minor">
+            <a:schemeClr val="lt1"/>
+          </a:fontRef>
+        </p:style>
+        <p:txBody>
+          <a:bodyPr rtlCol="0" anchor="ctr"/>
+          <a:lstStyle/>
+          <a:p>
+            <a:pPr algn="ctr"/>
+          </a:p>
+        </p:txBody>
+      </p:sp>
+      <p:sp>
+        <p:nvSpPr>
+          <p:cNvPr id="35" name="Rectangle 34"/>
+          <p:cNvSpPr/>
+          <p:nvPr/>
+        </p:nvSpPr>
+        <p:spPr>
+          <a:xfrm>
+            <a:off x="8253984" y="4736592"/>
+            <a:ext cx="3249168" cy="15875"/>
+          </a:xfrm>
+          <a:prstGeom prst="rect">
+            <a:avLst/>
+          </a:prstGeom>
+          <a:solidFill>
+            <a:srgbClr val="E2E8F0"/>
+          </a:solidFill>
+          <a:ln>
+            <a:noFill/>
+          </a:ln>
+        </p:spPr>
+        <p:style>
+          <a:lnRef idx="1">
+            <a:schemeClr val="accent1"/>
+          </a:lnRef>
+          <a:fillRef idx="3">
+            <a:schemeClr val="accent1"/>
+          </a:fillRef>
+          <a:effectRef idx="2">
+            <a:schemeClr val="accent1"/>
+          </a:effectRef>
+          <a:fontRef idx="minor">
+            <a:schemeClr val="lt1"/>
+          </a:fontRef>
+        </p:style>
+        <p:txBody>
+          <a:bodyPr rtlCol="0" anchor="ctr"/>
+          <a:lstStyle/>
+          <a:p>
+            <a:pPr algn="ctr"/>
+          </a:p>
+        </p:txBody>
+      </p:sp>
+      <p:sp>
+        <p:nvSpPr>
+          <p:cNvPr id="36" name="TextBox 35"/>
+          <p:cNvSpPr txBox="1"/>
+          <p:nvPr/>
+        </p:nvSpPr>
+        <p:spPr>
+          <a:xfrm>
+            <a:off x="457200" y="5742432"/>
+            <a:ext cx="11247120" cy="274320"/>
+          </a:xfrm>
+          <a:prstGeom prst="rect">
+            <a:avLst/>
+          </a:prstGeom>
+          <a:noFill/>
+        </p:spPr>
+        <p:txBody>
+          <a:bodyPr wrap="square" anchor="t"/>
+          <a:lstStyle/>
+          <a:p>
+            <a:pPr algn="l"/>
+            <a:r>
+              <a:rPr sz="1300" b="1" i="0" a:ea="Calibri">
+                <a:solidFill>
+                  <a:srgbClr val="9F1239"/>
+                </a:solidFill>
+                <a:latin typeface="Calibri"/>
+              </a:rPr>
+              <a:t>Think first — answers are on the next slide.</a:t>
+            </a:r>
+          </a:p>
+        </p:txBody>
+      </p:sp>
+      <p:sp>
+        <p:nvSpPr>
+          <p:cNvPr id="37" name="Rectangle 36"/>
+          <p:cNvSpPr/>
+          <p:nvPr/>
+        </p:nvSpPr>
+        <p:spPr>
+          <a:xfrm>
+            <a:off x="0" y="6437376"/>
+            <a:ext cx="12191695" cy="420624"/>
+          </a:xfrm>
+          <a:prstGeom prst="rect">
+            <a:avLst/>
+          </a:prstGeom>
+          <a:solidFill>
+            <a:srgbClr val="004D40"/>
+          </a:solidFill>
+          <a:ln>
+            <a:noFill/>
+          </a:ln>
+        </p:spPr>
+        <p:style>
+          <a:lnRef idx="1">
+            <a:schemeClr val="accent1"/>
+          </a:lnRef>
+          <a:fillRef idx="3">
+            <a:schemeClr val="accent1"/>
+          </a:fillRef>
+          <a:effectRef idx="2">
+            <a:schemeClr val="accent1"/>
+          </a:effectRef>
+          <a:fontRef idx="minor">
+            <a:schemeClr val="lt1"/>
+          </a:fontRef>
+        </p:style>
+        <p:txBody>
+          <a:bodyPr rtlCol="0" anchor="ctr"/>
+          <a:lstStyle/>
+          <a:p>
+            <a:pPr algn="ctr"/>
+          </a:p>
+        </p:txBody>
+      </p:sp>
       <p:pic>
         <p:nvPicPr>
-          <p:cNvPr id="23" name="Picture 22" descr="jdscience-footer-logo.png"/>
+          <p:cNvPr id="38" name="Picture 37" descr="jdscience-footer-logo.png"/>
           <p:cNvPicPr>
             <a:picLocks noChangeAspect="1"/>
           </p:cNvPicPr>
@@ -15032,7 +16103,7 @@
       </p:pic>
       <p:sp>
         <p:nvSpPr>
-          <p:cNvPr id="24" name="TextBox 23"/>
+          <p:cNvPr id="39" name="TextBox 38"/>
           <p:cNvSpPr txBox="1"/>
           <p:nvPr/>
         </p:nvSpPr>
@@ -15065,7 +16136,7 @@
       </p:sp>
       <p:sp>
         <p:nvSpPr>
-          <p:cNvPr id="25" name="TextBox 24"/>
+          <p:cNvPr id="40" name="TextBox 39"/>
           <p:cNvSpPr txBox="1"/>
           <p:nvPr/>
         </p:nvSpPr>
@@ -15098,7 +16169,7 @@
       </p:sp>
       <p:sp>
         <p:nvSpPr>
-          <p:cNvPr id="26" name="TextBox 25"/>
+          <p:cNvPr id="41" name="TextBox 40"/>
           <p:cNvSpPr txBox="1"/>
           <p:nvPr/>
         </p:nvSpPr>
@@ -20118,8 +21189,8 @@
         </p:nvSpPr>
         <p:spPr>
           <a:xfrm>
-            <a:off x="0" y="2880360"/>
-            <a:ext cx="12191695" cy="73152"/>
+            <a:off x="0" y="0"/>
+            <a:ext cx="146304" cy="6858000"/>
           </a:xfrm>
           <a:prstGeom prst="rect">
             <a:avLst/>
@@ -20161,80 +21232,80 @@
         </p:nvSpPr>
         <p:spPr>
           <a:xfrm>
+            <a:off x="640080" y="384048"/>
+            <a:ext cx="10972800" cy="868680"/>
+          </a:xfrm>
+          <a:prstGeom prst="rect">
+            <a:avLst/>
+          </a:prstGeom>
+          <a:noFill/>
+        </p:spPr>
+        <p:txBody>
+          <a:bodyPr wrap="square" anchor="t"/>
+          <a:lstStyle/>
+          <a:p>
+            <a:pPr algn="l"/>
+            <a:r>
+              <a:rPr sz="3000" b="1" i="0" a:ea="Calibri">
+                <a:solidFill>
+                  <a:srgbClr val="FFFFFF"/>
+                </a:solidFill>
+                <a:latin typeface="Calibri"/>
+              </a:rPr>
+              <a:t>The eukaryotic animal cell</a:t>
+            </a:r>
+          </a:p>
+        </p:txBody>
+      </p:sp>
+      <p:sp>
+        <p:nvSpPr>
+          <p:cNvPr id="5" name="TextBox 4"/>
+          <p:cNvSpPr txBox="1"/>
+          <p:nvPr/>
+        </p:nvSpPr>
+        <p:spPr>
+          <a:xfrm>
+            <a:off x="640080" y="1261872"/>
+            <a:ext cx="10972800" cy="502920"/>
+          </a:xfrm>
+          <a:prstGeom prst="rect">
+            <a:avLst/>
+          </a:prstGeom>
+          <a:noFill/>
+        </p:spPr>
+        <p:txBody>
+          <a:bodyPr wrap="square" anchor="t"/>
+          <a:lstStyle/>
+          <a:p>
+            <a:pPr algn="l"/>
+            <a:r>
+              <a:rPr sz="1700" b="0" i="0" a:ea="Calibri">
+                <a:solidFill>
+                  <a:srgbClr val="CCFBF1"/>
+                </a:solidFill>
+                <a:latin typeface="Calibri"/>
+              </a:rPr>
+              <a:t>Compartments with jobs</a:t>
+            </a:r>
+          </a:p>
+        </p:txBody>
+      </p:sp>
+      <p:sp>
+        <p:nvSpPr>
+          <p:cNvPr id="6" name="Rounded Rectangle 5"/>
+          <p:cNvSpPr/>
+          <p:nvPr/>
+        </p:nvSpPr>
+        <p:spPr>
+          <a:xfrm>
             <a:off x="640080" y="1965960"/>
-            <a:ext cx="10881360" cy="914400"/>
-          </a:xfrm>
-          <a:prstGeom prst="rect">
-            <a:avLst/>
-          </a:prstGeom>
-          <a:noFill/>
-        </p:spPr>
-        <p:txBody>
-          <a:bodyPr wrap="square" anchor="t"/>
-          <a:lstStyle/>
-          <a:p>
-            <a:pPr algn="l"/>
-            <a:r>
-              <a:rPr sz="3400" b="1" i="0" a:ea="Calibri">
-                <a:solidFill>
-                  <a:srgbClr val="FFFFFF"/>
-                </a:solidFill>
-                <a:latin typeface="Calibri"/>
-              </a:rPr>
-              <a:t>The eukaryotic animal cell</a:t>
-            </a:r>
-          </a:p>
-        </p:txBody>
-      </p:sp>
-      <p:sp>
-        <p:nvSpPr>
-          <p:cNvPr id="5" name="TextBox 4"/>
-          <p:cNvSpPr txBox="1"/>
-          <p:nvPr/>
-        </p:nvSpPr>
-        <p:spPr>
-          <a:xfrm>
-            <a:off x="640080" y="3154680"/>
-            <a:ext cx="10881360" cy="822960"/>
-          </a:xfrm>
-          <a:prstGeom prst="rect">
-            <a:avLst/>
-          </a:prstGeom>
-          <a:noFill/>
-        </p:spPr>
-        <p:txBody>
-          <a:bodyPr wrap="square" anchor="t"/>
-          <a:lstStyle/>
-          <a:p>
-            <a:pPr algn="l"/>
-            <a:r>
-              <a:rPr sz="1800" b="0" i="0" a:ea="Calibri">
-                <a:solidFill>
-                  <a:srgbClr val="CCFBF1"/>
-                </a:solidFill>
-                <a:latin typeface="Calibri"/>
-              </a:rPr>
-              <a:t>Compartments with jobs</a:t>
-            </a:r>
-          </a:p>
-        </p:txBody>
-      </p:sp>
-      <p:sp>
-        <p:nvSpPr>
-          <p:cNvPr id="6" name="Rectangle 5"/>
-          <p:cNvSpPr/>
-          <p:nvPr/>
-        </p:nvSpPr>
-        <p:spPr>
-          <a:xfrm>
-            <a:off x="0" y="6437376"/>
-            <a:ext cx="12191695" cy="420624"/>
-          </a:xfrm>
-          <a:prstGeom prst="rect">
-            <a:avLst/>
-          </a:prstGeom>
-          <a:solidFill>
-            <a:srgbClr val="004D40"/>
+            <a:ext cx="3520440" cy="3977639"/>
+          </a:xfrm>
+          <a:prstGeom prst="roundRect">
+            <a:avLst/>
+          </a:prstGeom>
+          <a:solidFill>
+            <a:srgbClr val="003D33"/>
           </a:solidFill>
           <a:ln>
             <a:noFill/>
@@ -20262,9 +21333,465 @@
           </a:p>
         </p:txBody>
       </p:sp>
+      <p:sp>
+        <p:nvSpPr>
+          <p:cNvPr id="7" name="Rectangle 6"/>
+          <p:cNvSpPr/>
+          <p:nvPr/>
+        </p:nvSpPr>
+        <p:spPr>
+          <a:xfrm>
+            <a:off x="640080" y="1965960"/>
+            <a:ext cx="3520440" cy="109728"/>
+          </a:xfrm>
+          <a:prstGeom prst="rect">
+            <a:avLst/>
+          </a:prstGeom>
+          <a:solidFill>
+            <a:srgbClr val="009688"/>
+          </a:solidFill>
+          <a:ln>
+            <a:noFill/>
+          </a:ln>
+        </p:spPr>
+        <p:style>
+          <a:lnRef idx="1">
+            <a:schemeClr val="accent1"/>
+          </a:lnRef>
+          <a:fillRef idx="3">
+            <a:schemeClr val="accent1"/>
+          </a:fillRef>
+          <a:effectRef idx="2">
+            <a:schemeClr val="accent1"/>
+          </a:effectRef>
+          <a:fontRef idx="minor">
+            <a:schemeClr val="lt1"/>
+          </a:fontRef>
+        </p:style>
+        <p:txBody>
+          <a:bodyPr rtlCol="0" anchor="ctr"/>
+          <a:lstStyle/>
+          <a:p>
+            <a:pPr algn="ctr"/>
+          </a:p>
+        </p:txBody>
+      </p:sp>
+      <p:sp>
+        <p:nvSpPr>
+          <p:cNvPr id="8" name="TextBox 7"/>
+          <p:cNvSpPr txBox="1"/>
+          <p:nvPr/>
+        </p:nvSpPr>
+        <p:spPr>
+          <a:xfrm>
+            <a:off x="841248" y="2212848"/>
+            <a:ext cx="3108960" cy="457200"/>
+          </a:xfrm>
+          <a:prstGeom prst="rect">
+            <a:avLst/>
+          </a:prstGeom>
+          <a:noFill/>
+        </p:spPr>
+        <p:txBody>
+          <a:bodyPr wrap="square" anchor="t"/>
+          <a:lstStyle/>
+          <a:p>
+            <a:pPr algn="l"/>
+            <a:r>
+              <a:rPr sz="1600" b="1" i="0" a:ea="Calibri">
+                <a:solidFill>
+                  <a:srgbClr val="CCFBF1"/>
+                </a:solidFill>
+                <a:latin typeface="Calibri"/>
+              </a:rPr>
+              <a:t>1   Look for</a:t>
+            </a:r>
+          </a:p>
+        </p:txBody>
+      </p:sp>
+      <p:sp>
+        <p:nvSpPr>
+          <p:cNvPr id="9" name="TextBox 8"/>
+          <p:cNvSpPr txBox="1"/>
+          <p:nvPr/>
+        </p:nvSpPr>
+        <p:spPr>
+          <a:xfrm>
+            <a:off x="841248" y="2788920"/>
+            <a:ext cx="3108960" cy="2880360"/>
+          </a:xfrm>
+          <a:prstGeom prst="rect">
+            <a:avLst/>
+          </a:prstGeom>
+          <a:noFill/>
+        </p:spPr>
+        <p:txBody>
+          <a:bodyPr wrap="square" anchor="t"/>
+          <a:lstStyle/>
+          <a:p>
+            <a:pPr algn="l"/>
+            <a:r>
+              <a:rPr sz="1600" b="0" i="0" a:ea="Calibri">
+                <a:solidFill>
+                  <a:srgbClr val="FFFFFF"/>
+                </a:solidFill>
+                <a:latin typeface="Calibri"/>
+              </a:rPr>
+              <a:t>Leader lines to the nucleus, mitochondrion, RER, membrane and cytoplasm.</a:t>
+            </a:r>
+          </a:p>
+        </p:txBody>
+      </p:sp>
+      <p:sp>
+        <p:nvSpPr>
+          <p:cNvPr id="10" name="Rounded Rectangle 9"/>
+          <p:cNvSpPr/>
+          <p:nvPr/>
+        </p:nvSpPr>
+        <p:spPr>
+          <a:xfrm>
+            <a:off x="4343400" y="1965960"/>
+            <a:ext cx="3520440" cy="3977639"/>
+          </a:xfrm>
+          <a:prstGeom prst="roundRect">
+            <a:avLst/>
+          </a:prstGeom>
+          <a:solidFill>
+            <a:srgbClr val="003D33"/>
+          </a:solidFill>
+          <a:ln>
+            <a:noFill/>
+          </a:ln>
+        </p:spPr>
+        <p:style>
+          <a:lnRef idx="1">
+            <a:schemeClr val="accent1"/>
+          </a:lnRef>
+          <a:fillRef idx="3">
+            <a:schemeClr val="accent1"/>
+          </a:fillRef>
+          <a:effectRef idx="2">
+            <a:schemeClr val="accent1"/>
+          </a:effectRef>
+          <a:fontRef idx="minor">
+            <a:schemeClr val="lt1"/>
+          </a:fontRef>
+        </p:style>
+        <p:txBody>
+          <a:bodyPr rtlCol="0" anchor="ctr"/>
+          <a:lstStyle/>
+          <a:p>
+            <a:pPr algn="ctr"/>
+          </a:p>
+        </p:txBody>
+      </p:sp>
+      <p:sp>
+        <p:nvSpPr>
+          <p:cNvPr id="11" name="Rectangle 10"/>
+          <p:cNvSpPr/>
+          <p:nvPr/>
+        </p:nvSpPr>
+        <p:spPr>
+          <a:xfrm>
+            <a:off x="4343400" y="1965960"/>
+            <a:ext cx="3520440" cy="109728"/>
+          </a:xfrm>
+          <a:prstGeom prst="rect">
+            <a:avLst/>
+          </a:prstGeom>
+          <a:solidFill>
+            <a:srgbClr val="99F6E4"/>
+          </a:solidFill>
+          <a:ln>
+            <a:noFill/>
+          </a:ln>
+        </p:spPr>
+        <p:style>
+          <a:lnRef idx="1">
+            <a:schemeClr val="accent1"/>
+          </a:lnRef>
+          <a:fillRef idx="3">
+            <a:schemeClr val="accent1"/>
+          </a:fillRef>
+          <a:effectRef idx="2">
+            <a:schemeClr val="accent1"/>
+          </a:effectRef>
+          <a:fontRef idx="minor">
+            <a:schemeClr val="lt1"/>
+          </a:fontRef>
+        </p:style>
+        <p:txBody>
+          <a:bodyPr rtlCol="0" anchor="ctr"/>
+          <a:lstStyle/>
+          <a:p>
+            <a:pPr algn="ctr"/>
+          </a:p>
+        </p:txBody>
+      </p:sp>
+      <p:sp>
+        <p:nvSpPr>
+          <p:cNvPr id="12" name="TextBox 11"/>
+          <p:cNvSpPr txBox="1"/>
+          <p:nvPr/>
+        </p:nvSpPr>
+        <p:spPr>
+          <a:xfrm>
+            <a:off x="4544568" y="2212848"/>
+            <a:ext cx="3108960" cy="457200"/>
+          </a:xfrm>
+          <a:prstGeom prst="rect">
+            <a:avLst/>
+          </a:prstGeom>
+          <a:noFill/>
+        </p:spPr>
+        <p:txBody>
+          <a:bodyPr wrap="square" anchor="t"/>
+          <a:lstStyle/>
+          <a:p>
+            <a:pPr algn="l"/>
+            <a:r>
+              <a:rPr sz="1600" b="1" i="0" a:ea="Calibri">
+                <a:solidFill>
+                  <a:srgbClr val="CCFBF1"/>
+                </a:solidFill>
+                <a:latin typeface="Calibri"/>
+              </a:rPr>
+              <a:t>2   Say in full</a:t>
+            </a:r>
+          </a:p>
+        </p:txBody>
+      </p:sp>
+      <p:sp>
+        <p:nvSpPr>
+          <p:cNvPr id="13" name="TextBox 12"/>
+          <p:cNvSpPr txBox="1"/>
+          <p:nvPr/>
+        </p:nvSpPr>
+        <p:spPr>
+          <a:xfrm>
+            <a:off x="4544568" y="2788920"/>
+            <a:ext cx="3108960" cy="2880360"/>
+          </a:xfrm>
+          <a:prstGeom prst="rect">
+            <a:avLst/>
+          </a:prstGeom>
+          <a:noFill/>
+        </p:spPr>
+        <p:txBody>
+          <a:bodyPr wrap="square" anchor="t"/>
+          <a:lstStyle/>
+          <a:p>
+            <a:pPr algn="l"/>
+            <a:r>
+              <a:rPr sz="1600" b="0" i="0" a:ea="Calibri">
+                <a:solidFill>
+                  <a:srgbClr val="FFFFFF"/>
+                </a:solidFill>
+                <a:latin typeface="Calibri"/>
+              </a:rPr>
+              <a:t>Each organelle has a structure that matches its function.</a:t>
+            </a:r>
+          </a:p>
+        </p:txBody>
+      </p:sp>
+      <p:sp>
+        <p:nvSpPr>
+          <p:cNvPr id="14" name="Rounded Rectangle 13"/>
+          <p:cNvSpPr/>
+          <p:nvPr/>
+        </p:nvSpPr>
+        <p:spPr>
+          <a:xfrm>
+            <a:off x="8046720" y="1965960"/>
+            <a:ext cx="3520440" cy="3977639"/>
+          </a:xfrm>
+          <a:prstGeom prst="roundRect">
+            <a:avLst/>
+          </a:prstGeom>
+          <a:solidFill>
+            <a:srgbClr val="003D33"/>
+          </a:solidFill>
+          <a:ln>
+            <a:noFill/>
+          </a:ln>
+        </p:spPr>
+        <p:style>
+          <a:lnRef idx="1">
+            <a:schemeClr val="accent1"/>
+          </a:lnRef>
+          <a:fillRef idx="3">
+            <a:schemeClr val="accent1"/>
+          </a:fillRef>
+          <a:effectRef idx="2">
+            <a:schemeClr val="accent1"/>
+          </a:effectRef>
+          <a:fontRef idx="minor">
+            <a:schemeClr val="lt1"/>
+          </a:fontRef>
+        </p:style>
+        <p:txBody>
+          <a:bodyPr rtlCol="0" anchor="ctr"/>
+          <a:lstStyle/>
+          <a:p>
+            <a:pPr algn="ctr"/>
+          </a:p>
+        </p:txBody>
+      </p:sp>
+      <p:sp>
+        <p:nvSpPr>
+          <p:cNvPr id="15" name="Rectangle 14"/>
+          <p:cNvSpPr/>
+          <p:nvPr/>
+        </p:nvSpPr>
+        <p:spPr>
+          <a:xfrm>
+            <a:off x="8046720" y="1965960"/>
+            <a:ext cx="3520440" cy="109728"/>
+          </a:xfrm>
+          <a:prstGeom prst="rect">
+            <a:avLst/>
+          </a:prstGeom>
+          <a:solidFill>
+            <a:srgbClr val="5EEAD4"/>
+          </a:solidFill>
+          <a:ln>
+            <a:noFill/>
+          </a:ln>
+        </p:spPr>
+        <p:style>
+          <a:lnRef idx="1">
+            <a:schemeClr val="accent1"/>
+          </a:lnRef>
+          <a:fillRef idx="3">
+            <a:schemeClr val="accent1"/>
+          </a:fillRef>
+          <a:effectRef idx="2">
+            <a:schemeClr val="accent1"/>
+          </a:effectRef>
+          <a:fontRef idx="minor">
+            <a:schemeClr val="lt1"/>
+          </a:fontRef>
+        </p:style>
+        <p:txBody>
+          <a:bodyPr rtlCol="0" anchor="ctr"/>
+          <a:lstStyle/>
+          <a:p>
+            <a:pPr algn="ctr"/>
+          </a:p>
+        </p:txBody>
+      </p:sp>
+      <p:sp>
+        <p:nvSpPr>
+          <p:cNvPr id="16" name="TextBox 15"/>
+          <p:cNvSpPr txBox="1"/>
+          <p:nvPr/>
+        </p:nvSpPr>
+        <p:spPr>
+          <a:xfrm>
+            <a:off x="8247888" y="2212848"/>
+            <a:ext cx="3108960" cy="457200"/>
+          </a:xfrm>
+          <a:prstGeom prst="rect">
+            <a:avLst/>
+          </a:prstGeom>
+          <a:noFill/>
+        </p:spPr>
+        <p:txBody>
+          <a:bodyPr wrap="square" anchor="t"/>
+          <a:lstStyle/>
+          <a:p>
+            <a:pPr algn="l"/>
+            <a:r>
+              <a:rPr sz="1600" b="1" i="0" a:ea="Calibri">
+                <a:solidFill>
+                  <a:srgbClr val="CCFBF1"/>
+                </a:solidFill>
+                <a:latin typeface="Calibri"/>
+              </a:rPr>
+              <a:t>3   Level 3 move</a:t>
+            </a:r>
+          </a:p>
+        </p:txBody>
+      </p:sp>
+      <p:sp>
+        <p:nvSpPr>
+          <p:cNvPr id="17" name="TextBox 16"/>
+          <p:cNvSpPr txBox="1"/>
+          <p:nvPr/>
+        </p:nvSpPr>
+        <p:spPr>
+          <a:xfrm>
+            <a:off x="8247888" y="2788920"/>
+            <a:ext cx="3108960" cy="2880360"/>
+          </a:xfrm>
+          <a:prstGeom prst="rect">
+            <a:avLst/>
+          </a:prstGeom>
+          <a:noFill/>
+        </p:spPr>
+        <p:txBody>
+          <a:bodyPr wrap="square" anchor="t"/>
+          <a:lstStyle/>
+          <a:p>
+            <a:pPr algn="l"/>
+            <a:r>
+              <a:rPr sz="1600" b="0" i="0" a:ea="Calibri">
+                <a:solidFill>
+                  <a:srgbClr val="FFFFFF"/>
+                </a:solidFill>
+                <a:latin typeface="Calibri"/>
+              </a:rPr>
+              <a:t>Name ultrastructure: envelope, cristae, ribosomes — not just ‘it makes energy’.</a:t>
+            </a:r>
+          </a:p>
+        </p:txBody>
+      </p:sp>
+      <p:sp>
+        <p:nvSpPr>
+          <p:cNvPr id="18" name="Rectangle 17"/>
+          <p:cNvSpPr/>
+          <p:nvPr/>
+        </p:nvSpPr>
+        <p:spPr>
+          <a:xfrm>
+            <a:off x="0" y="6437376"/>
+            <a:ext cx="12191695" cy="420624"/>
+          </a:xfrm>
+          <a:prstGeom prst="rect">
+            <a:avLst/>
+          </a:prstGeom>
+          <a:solidFill>
+            <a:srgbClr val="004D40"/>
+          </a:solidFill>
+          <a:ln>
+            <a:noFill/>
+          </a:ln>
+        </p:spPr>
+        <p:style>
+          <a:lnRef idx="1">
+            <a:schemeClr val="accent1"/>
+          </a:lnRef>
+          <a:fillRef idx="3">
+            <a:schemeClr val="accent1"/>
+          </a:fillRef>
+          <a:effectRef idx="2">
+            <a:schemeClr val="accent1"/>
+          </a:effectRef>
+          <a:fontRef idx="minor">
+            <a:schemeClr val="lt1"/>
+          </a:fontRef>
+        </p:style>
+        <p:txBody>
+          <a:bodyPr rtlCol="0" anchor="ctr"/>
+          <a:lstStyle/>
+          <a:p>
+            <a:pPr algn="ctr"/>
+          </a:p>
+        </p:txBody>
+      </p:sp>
       <p:pic>
         <p:nvPicPr>
-          <p:cNvPr id="7" name="Picture 6" descr="jdscience-footer-logo.png"/>
+          <p:cNvPr id="19" name="Picture 18" descr="jdscience-footer-logo.png"/>
           <p:cNvPicPr>
             <a:picLocks noChangeAspect="1"/>
           </p:cNvPicPr>
@@ -20288,7 +21815,7 @@
       </p:pic>
       <p:sp>
         <p:nvSpPr>
-          <p:cNvPr id="8" name="TextBox 7"/>
+          <p:cNvPr id="20" name="TextBox 19"/>
           <p:cNvSpPr txBox="1"/>
           <p:nvPr/>
         </p:nvSpPr>
@@ -20321,7 +21848,7 @@
       </p:sp>
       <p:sp>
         <p:nvSpPr>
-          <p:cNvPr id="9" name="TextBox 8"/>
+          <p:cNvPr id="21" name="TextBox 20"/>
           <p:cNvSpPr txBox="1"/>
           <p:nvPr/>
         </p:nvSpPr>
@@ -20354,7 +21881,7 @@
       </p:sp>
       <p:sp>
         <p:nvSpPr>
-          <p:cNvPr id="10" name="TextBox 9"/>
+          <p:cNvPr id="22" name="TextBox 21"/>
           <p:cNvSpPr txBox="1"/>
           <p:nvPr/>
         </p:nvSpPr>
@@ -20597,8 +22124,8 @@
         </p:nvSpPr>
         <p:spPr>
           <a:xfrm>
-            <a:off x="6931152" y="1069848"/>
-            <a:ext cx="4617720" cy="685800"/>
+            <a:off x="6931152" y="1051560"/>
+            <a:ext cx="4617720" cy="722376"/>
           </a:xfrm>
           <a:prstGeom prst="rect">
             <a:avLst/>
@@ -20716,8 +22243,8 @@
         </p:nvSpPr>
         <p:spPr>
           <a:xfrm>
-            <a:off x="6931152" y="2029968"/>
-            <a:ext cx="4617720" cy="685800"/>
+            <a:off x="6931152" y="2011680"/>
+            <a:ext cx="4617720" cy="722376"/>
           </a:xfrm>
           <a:prstGeom prst="rect">
             <a:avLst/>
@@ -20835,8 +22362,8 @@
         </p:nvSpPr>
         <p:spPr>
           <a:xfrm>
-            <a:off x="6931152" y="2990088"/>
-            <a:ext cx="4617720" cy="685800"/>
+            <a:off x="6931152" y="2971800"/>
+            <a:ext cx="4617720" cy="722376"/>
           </a:xfrm>
           <a:prstGeom prst="rect">
             <a:avLst/>
@@ -20954,8 +22481,8 @@
         </p:nvSpPr>
         <p:spPr>
           <a:xfrm>
-            <a:off x="6931152" y="3950208"/>
-            <a:ext cx="4617720" cy="685800"/>
+            <a:off x="6931152" y="3931920"/>
+            <a:ext cx="4617720" cy="722376"/>
           </a:xfrm>
           <a:prstGeom prst="rect">
             <a:avLst/>
@@ -21073,8 +22600,8 @@
         </p:nvSpPr>
         <p:spPr>
           <a:xfrm>
-            <a:off x="6931152" y="4910328"/>
-            <a:ext cx="4617720" cy="685800"/>
+            <a:off x="6931152" y="4892040"/>
+            <a:ext cx="4617720" cy="722376"/>
           </a:xfrm>
           <a:prstGeom prst="rect">
             <a:avLst/>
@@ -21509,8 +23036,8 @@
         </p:nvSpPr>
         <p:spPr>
           <a:xfrm>
-            <a:off x="6931152" y="1069848"/>
-            <a:ext cx="4617720" cy="685800"/>
+            <a:off x="6931152" y="1051560"/>
+            <a:ext cx="4617720" cy="722376"/>
           </a:xfrm>
           <a:prstGeom prst="rect">
             <a:avLst/>
@@ -21628,8 +23155,8 @@
         </p:nvSpPr>
         <p:spPr>
           <a:xfrm>
-            <a:off x="6931152" y="2029968"/>
-            <a:ext cx="4617720" cy="685800"/>
+            <a:off x="6931152" y="2011680"/>
+            <a:ext cx="4617720" cy="722376"/>
           </a:xfrm>
           <a:prstGeom prst="rect">
             <a:avLst/>
@@ -21747,8 +23274,8 @@
         </p:nvSpPr>
         <p:spPr>
           <a:xfrm>
-            <a:off x="6931152" y="2990088"/>
-            <a:ext cx="4617720" cy="685800"/>
+            <a:off x="6931152" y="2971800"/>
+            <a:ext cx="4617720" cy="722376"/>
           </a:xfrm>
           <a:prstGeom prst="rect">
             <a:avLst/>
@@ -21866,8 +23393,8 @@
         </p:nvSpPr>
         <p:spPr>
           <a:xfrm>
-            <a:off x="6931152" y="3950208"/>
-            <a:ext cx="4617720" cy="685800"/>
+            <a:off x="6931152" y="3931920"/>
+            <a:ext cx="4617720" cy="722376"/>
           </a:xfrm>
           <a:prstGeom prst="rect">
             <a:avLst/>
@@ -21985,8 +23512,8 @@
         </p:nvSpPr>
         <p:spPr>
           <a:xfrm>
-            <a:off x="6931152" y="4910328"/>
-            <a:ext cx="4617720" cy="685800"/>
+            <a:off x="6931152" y="4892040"/>
+            <a:ext cx="4617720" cy="722376"/>
           </a:xfrm>
           <a:prstGeom prst="rect">
             <a:avLst/>
@@ -22388,8 +23915,8 @@
         </p:nvSpPr>
         <p:spPr>
           <a:xfrm>
-            <a:off x="6931152" y="1069848"/>
-            <a:ext cx="4617720" cy="685800"/>
+            <a:off x="6931152" y="1051560"/>
+            <a:ext cx="4617720" cy="722376"/>
           </a:xfrm>
           <a:prstGeom prst="rect">
             <a:avLst/>
@@ -22507,8 +24034,8 @@
         </p:nvSpPr>
         <p:spPr>
           <a:xfrm>
-            <a:off x="6931152" y="2029968"/>
-            <a:ext cx="4617720" cy="685800"/>
+            <a:off x="6931152" y="2011680"/>
+            <a:ext cx="4617720" cy="722376"/>
           </a:xfrm>
           <a:prstGeom prst="rect">
             <a:avLst/>
@@ -22626,8 +24153,8 @@
         </p:nvSpPr>
         <p:spPr>
           <a:xfrm>
-            <a:off x="6931152" y="2990088"/>
-            <a:ext cx="4617720" cy="685800"/>
+            <a:off x="6931152" y="2971800"/>
+            <a:ext cx="4617720" cy="722376"/>
           </a:xfrm>
           <a:prstGeom prst="rect">
             <a:avLst/>
@@ -22745,8 +24272,8 @@
         </p:nvSpPr>
         <p:spPr>
           <a:xfrm>
-            <a:off x="6931152" y="3950208"/>
-            <a:ext cx="4617720" cy="685800"/>
+            <a:off x="6931152" y="3931920"/>
+            <a:ext cx="4617720" cy="722376"/>
           </a:xfrm>
           <a:prstGeom prst="rect">
             <a:avLst/>
@@ -22864,8 +24391,8 @@
         </p:nvSpPr>
         <p:spPr>
           <a:xfrm>
-            <a:off x="6931152" y="4910328"/>
-            <a:ext cx="4617720" cy="685800"/>
+            <a:off x="6931152" y="4892040"/>
+            <a:ext cx="4617720" cy="722376"/>
           </a:xfrm>
           <a:prstGeom prst="rect">
             <a:avLst/>

</xml_diff>